<commit_message>
Replace presentation with updated version
</commit_message>
<xml_diff>
--- a/Presentation.pptx
+++ b/Presentation.pptx
@@ -5,7 +5,7 @@
     <p:sldMasterId id="2147483648" r:id="rId1"/>
   </p:sldMasterIdLst>
   <p:notesMasterIdLst>
-    <p:notesMasterId r:id="rId38"/>
+    <p:notesMasterId r:id="rId41"/>
   </p:notesMasterIdLst>
   <p:sldIdLst>
     <p:sldId id="283" r:id="rId2"/>
@@ -22,28 +22,31 @@
     <p:sldId id="291" r:id="rId13"/>
     <p:sldId id="294" r:id="rId14"/>
     <p:sldId id="295" r:id="rId15"/>
-    <p:sldId id="296" r:id="rId16"/>
-    <p:sldId id="297" r:id="rId17"/>
-    <p:sldId id="298" r:id="rId18"/>
-    <p:sldId id="299" r:id="rId19"/>
-    <p:sldId id="300" r:id="rId20"/>
-    <p:sldId id="301" r:id="rId21"/>
-    <p:sldId id="302" r:id="rId22"/>
-    <p:sldId id="303" r:id="rId23"/>
-    <p:sldId id="304" r:id="rId24"/>
-    <p:sldId id="305" r:id="rId25"/>
-    <p:sldId id="306" r:id="rId26"/>
-    <p:sldId id="286" r:id="rId27"/>
-    <p:sldId id="287" r:id="rId28"/>
-    <p:sldId id="280" r:id="rId29"/>
-    <p:sldId id="307" r:id="rId30"/>
-    <p:sldId id="288" r:id="rId31"/>
-    <p:sldId id="308" r:id="rId32"/>
-    <p:sldId id="309" r:id="rId33"/>
-    <p:sldId id="310" r:id="rId34"/>
-    <p:sldId id="311" r:id="rId35"/>
-    <p:sldId id="289" r:id="rId36"/>
-    <p:sldId id="276" r:id="rId37"/>
+    <p:sldId id="314" r:id="rId16"/>
+    <p:sldId id="315" r:id="rId17"/>
+    <p:sldId id="313" r:id="rId18"/>
+    <p:sldId id="296" r:id="rId19"/>
+    <p:sldId id="297" r:id="rId20"/>
+    <p:sldId id="298" r:id="rId21"/>
+    <p:sldId id="299" r:id="rId22"/>
+    <p:sldId id="300" r:id="rId23"/>
+    <p:sldId id="301" r:id="rId24"/>
+    <p:sldId id="302" r:id="rId25"/>
+    <p:sldId id="303" r:id="rId26"/>
+    <p:sldId id="304" r:id="rId27"/>
+    <p:sldId id="305" r:id="rId28"/>
+    <p:sldId id="306" r:id="rId29"/>
+    <p:sldId id="286" r:id="rId30"/>
+    <p:sldId id="287" r:id="rId31"/>
+    <p:sldId id="280" r:id="rId32"/>
+    <p:sldId id="307" r:id="rId33"/>
+    <p:sldId id="288" r:id="rId34"/>
+    <p:sldId id="308" r:id="rId35"/>
+    <p:sldId id="309" r:id="rId36"/>
+    <p:sldId id="310" r:id="rId37"/>
+    <p:sldId id="311" r:id="rId38"/>
+    <p:sldId id="289" r:id="rId39"/>
+    <p:sldId id="276" r:id="rId40"/>
   </p:sldIdLst>
   <p:sldSz cx="12192000" cy="6858000"/>
   <p:notesSz cx="6858000" cy="9144000"/>
@@ -278,7 +281,7 @@
   </p:defaultTextStyle>
   <p:extLst>
     <p:ext uri="GoogleSlidesCustomDataVersion2">
-      <go:slidesCustomData xmlns:mc="http://schemas.openxmlformats.org/markup-compatibility/2006" xmlns:mv="urn:schemas-microsoft-com:mac:vml" xmlns:c="http://schemas.openxmlformats.org/drawingml/2006/chart" xmlns:dgm="http://schemas.openxmlformats.org/drawingml/2006/diagram" xmlns:o="urn:schemas-microsoft-com:office:office" xmlns:v="urn:schemas-microsoft-com:vml" xmlns:pvml="urn:schemas-microsoft-com:office:powerpoint" xmlns:com="http://schemas.openxmlformats.org/drawingml/2006/compatibility" xmlns:p14="http://schemas.microsoft.com/office/powerpoint/2010/main" xmlns:p15="http://schemas.microsoft.com/office/powerpoint/2012/main" xmlns:ahyp="http://schemas.microsoft.com/office/drawing/2018/hyperlinkcolor" xmlns:go="http://customooxmlschemas.google.com/" xmlns="" r:id="rId39" roundtripDataSignature="AMtx7mjt3491jQ7aCoyIz2WXeHKroE7tpQ=="/>
+      <go:slidesCustomData xmlns:mc="http://schemas.openxmlformats.org/markup-compatibility/2006" xmlns:mv="urn:schemas-microsoft-com:mac:vml" xmlns:c="http://schemas.openxmlformats.org/drawingml/2006/chart" xmlns:dgm="http://schemas.openxmlformats.org/drawingml/2006/diagram" xmlns:o="urn:schemas-microsoft-com:office:office" xmlns:v="urn:schemas-microsoft-com:vml" xmlns:pvml="urn:schemas-microsoft-com:office:powerpoint" xmlns:com="http://schemas.openxmlformats.org/drawingml/2006/compatibility" xmlns:p14="http://schemas.microsoft.com/office/powerpoint/2010/main" xmlns:p15="http://schemas.microsoft.com/office/powerpoint/2012/main" xmlns:ahyp="http://schemas.microsoft.com/office/drawing/2018/hyperlinkcolor" xmlns:go="http://customooxmlschemas.google.com/" xmlns="" r:id="rId42" roundtripDataSignature="AMtx7mjt3491jQ7aCoyIz2WXeHKroE7tpQ=="/>
     </p:ext>
   </p:extLst>
 </p:presentation>
@@ -288,6 +291,7 @@
 <p1510:revInfo xmlns:a="http://schemas.openxmlformats.org/drawingml/2006/main" xmlns:r="http://schemas.openxmlformats.org/officeDocument/2006/relationships" xmlns:p1510="http://schemas.microsoft.com/office/powerpoint/2015/10/main">
   <p1510:revLst>
     <p1510:client id="{BC6C625E-2413-4F67-B82F-E0F3B81560BA}" v="47" dt="2026-07-06T12:35:19.838"/>
+    <p1510:client id="{D917197F-09A5-4C68-89F6-E42E23B3C25E}" v="110" dt="2026-07-08T12:28:23.578"/>
   </p1510:revLst>
 </p1510:revInfo>
 </file>
@@ -11900,7 +11904,7 @@
         <p:spPr>
           <a:xfrm>
             <a:off x="414759" y="207380"/>
-            <a:ext cx="2816507" cy="677108"/>
+            <a:ext cx="5392792" cy="677108"/>
           </a:xfrm>
           <a:prstGeom prst="rect">
             <a:avLst/>
@@ -11921,7 +11925,6 @@
                 <a:solidFill>
                   <a:srgbClr val="000000"/>
                 </a:solidFill>
-                <a:latin typeface="Calibri"/>
               </a:rPr>
               <a:t>Testing Screenshot:</a:t>
             </a:r>
@@ -12611,6 +12614,439 @@
           <p:cNvPr id="2" name="TextBox 1">
             <a:extLst>
               <a:ext uri="{FF2B5EF4-FFF2-40B4-BE49-F238E27FC236}">
+                <a16:creationId xmlns:a16="http://schemas.microsoft.com/office/drawing/2014/main" id="{669CDD98-5253-EA76-E013-E7E4EBE547DE}"/>
+              </a:ext>
+            </a:extLst>
+          </p:cNvPr>
+          <p:cNvSpPr txBox="1"/>
+          <p:nvPr/>
+        </p:nvSpPr>
+        <p:spPr>
+          <a:xfrm>
+            <a:off x="445340" y="372829"/>
+            <a:ext cx="8964893" cy="461665"/>
+          </a:xfrm>
+          <a:prstGeom prst="rect">
+            <a:avLst/>
+          </a:prstGeom>
+          <a:noFill/>
+        </p:spPr>
+        <p:txBody>
+          <a:bodyPr rot="0" spcFirstLastPara="0" vertOverflow="overflow" horzOverflow="overflow" vert="horz" wrap="square" lIns="91440" tIns="45720" rIns="91440" bIns="45720" numCol="1" spcCol="0" rtlCol="0" fromWordArt="0" anchor="t" anchorCtr="0" forceAA="0" compatLnSpc="1">
+            <a:prstTxWarp prst="textNoShape">
+              <a:avLst/>
+            </a:prstTxWarp>
+            <a:spAutoFit/>
+          </a:bodyPr>
+          <a:lstStyle/>
+          <a:p>
+            <a:r>
+              <a:rPr lang="en-US" sz="2400" b="1"/>
+              <a:t>IBM Bob Prompt-</a:t>
+            </a:r>
+            <a:r>
+              <a:rPr lang="en-US" b="1"/>
+              <a:t> </a:t>
+            </a:r>
+          </a:p>
+        </p:txBody>
+      </p:sp>
+      <p:sp>
+        <p:nvSpPr>
+          <p:cNvPr id="3" name="TextBox 2">
+            <a:extLst>
+              <a:ext uri="{FF2B5EF4-FFF2-40B4-BE49-F238E27FC236}">
+                <a16:creationId xmlns:a16="http://schemas.microsoft.com/office/drawing/2014/main" id="{3E2AB1BC-CCDD-D763-5218-32D7F19926DE}"/>
+              </a:ext>
+            </a:extLst>
+          </p:cNvPr>
+          <p:cNvSpPr txBox="1"/>
+          <p:nvPr/>
+        </p:nvSpPr>
+        <p:spPr>
+          <a:xfrm>
+            <a:off x="444967" y="1008066"/>
+            <a:ext cx="11218154" cy="6821804"/>
+          </a:xfrm>
+          <a:prstGeom prst="rect">
+            <a:avLst/>
+          </a:prstGeom>
+          <a:noFill/>
+        </p:spPr>
+        <p:txBody>
+          <a:bodyPr rot="0" spcFirstLastPara="0" vertOverflow="overflow" horzOverflow="overflow" vert="horz" wrap="square" lIns="91440" tIns="45720" rIns="91440" bIns="45720" numCol="1" spcCol="0" rtlCol="0" fromWordArt="0" anchor="t" anchorCtr="0" forceAA="0" compatLnSpc="1">
+            <a:prstTxWarp prst="textNoShape">
+              <a:avLst/>
+            </a:prstTxWarp>
+            <a:spAutoFit/>
+          </a:bodyPr>
+          <a:lstStyle/>
+          <a:p>
+            <a:pPr>
+              <a:lnSpc>
+                <a:spcPct val="150000"/>
+              </a:lnSpc>
+            </a:pPr>
+            <a:r>
+              <a:rPr lang="en-US" sz="2000" dirty="0"/>
+              <a:t>Create an AI-powered Breast Cancer Prevention and Risk Prediction web application using Python Flask, IBM Cloud, and IBM </a:t>
+            </a:r>
+            <a:r>
+              <a:rPr lang="en-US" sz="2000" dirty="0" err="1"/>
+              <a:t>AutoAI</a:t>
+            </a:r>
+            <a:r>
+              <a:rPr lang="en-US" sz="2000" dirty="0"/>
+              <a:t>. Use the Breast Cancer Wisconsin Diagnosis dataset, where the target/output column is diagnosis, with M meaning Malignant and B meaning Benign. Exclude id and Unnamed: 32 from model training.</a:t>
+            </a:r>
+            <a:endParaRPr lang="en-US"/>
+          </a:p>
+          <a:p>
+            <a:pPr>
+              <a:lnSpc>
+                <a:spcPct val="150000"/>
+              </a:lnSpc>
+            </a:pPr>
+            <a:r>
+              <a:rPr lang="en-US" sz="2000" dirty="0"/>
+              <a:t>Build a responsive healthcare-focused frontend where users can enter tumor cell measurement values and receive an ML-based prediction result from the </a:t>
+            </a:r>
+            <a:r>
+              <a:rPr lang="en-US" sz="2000" dirty="0" err="1"/>
+              <a:t>AutoAI</a:t>
+            </a:r>
+            <a:r>
+              <a:rPr lang="en-US" sz="2000" dirty="0"/>
+              <a:t> model. The website should show whether the case is predicted as Benign or Malignant, along with confidence/probability if available.</a:t>
+            </a:r>
+          </a:p>
+          <a:p>
+            <a:pPr>
+              <a:lnSpc>
+                <a:spcPct val="150000"/>
+              </a:lnSpc>
+            </a:pPr>
+            <a:r>
+              <a:rPr lang="en-US" sz="2000"/>
+              <a:t>Add a dashboard explaining key features such as radius, texture, perimeter, area, smoothness, compactness, concavity, symmetry, and fractal dimension. Include prevention awareness sections, early detection tips, risk factors, and a disclaimer that this tool is for educational purposes only and not a medical diagnosis.</a:t>
+            </a:r>
+            <a:endParaRPr lang="en-US" sz="2000" dirty="0"/>
+          </a:p>
+          <a:p>
+            <a:pPr>
+              <a:lnSpc>
+                <a:spcPct val="150000"/>
+              </a:lnSpc>
+            </a:pPr>
+            <a:br>
+              <a:rPr lang="en-US" dirty="0"/>
+            </a:br>
+            <a:endParaRPr lang="en-US" sz="2000" dirty="0"/>
+          </a:p>
+          <a:p>
+            <a:pPr>
+              <a:lnSpc>
+                <a:spcPct val="150000"/>
+              </a:lnSpc>
+            </a:pPr>
+            <a:endParaRPr lang="en-US" sz="2000" dirty="0"/>
+          </a:p>
+        </p:txBody>
+      </p:sp>
+    </p:spTree>
+    <p:extLst>
+      <p:ext uri="{BB962C8B-B14F-4D97-AF65-F5344CB8AC3E}">
+        <p14:creationId xmlns:p14="http://schemas.microsoft.com/office/powerpoint/2010/main" val="2801110190"/>
+      </p:ext>
+    </p:extLst>
+  </p:cSld>
+  <p:clrMapOvr>
+    <a:masterClrMapping/>
+  </p:clrMapOvr>
+</p:sld>
+</file>
+
+<file path=ppt/slides/slide16.xml><?xml version="1.0" encoding="utf-8"?>
+<p:sld xmlns:a="http://schemas.openxmlformats.org/drawingml/2006/main" xmlns:r="http://schemas.openxmlformats.org/officeDocument/2006/relationships" xmlns:p="http://schemas.openxmlformats.org/presentationml/2006/main">
+  <p:cSld>
+    <p:spTree>
+      <p:nvGrpSpPr>
+        <p:cNvPr id="1" name=""/>
+        <p:cNvGrpSpPr/>
+        <p:nvPr/>
+      </p:nvGrpSpPr>
+      <p:grpSpPr>
+        <a:xfrm>
+          <a:off x="0" y="0"/>
+          <a:ext cx="0" cy="0"/>
+          <a:chOff x="0" y="0"/>
+          <a:chExt cx="0" cy="0"/>
+        </a:xfrm>
+      </p:grpSpPr>
+      <p:sp>
+        <p:nvSpPr>
+          <p:cNvPr id="2" name="TextBox 1">
+            <a:extLst>
+              <a:ext uri="{FF2B5EF4-FFF2-40B4-BE49-F238E27FC236}">
+                <a16:creationId xmlns:a16="http://schemas.microsoft.com/office/drawing/2014/main" id="{C83BDBAC-650B-6123-7648-9C592B28F526}"/>
+              </a:ext>
+            </a:extLst>
+          </p:cNvPr>
+          <p:cNvSpPr txBox="1"/>
+          <p:nvPr/>
+        </p:nvSpPr>
+        <p:spPr>
+          <a:xfrm>
+            <a:off x="290150" y="290150"/>
+            <a:ext cx="11486533" cy="3266985"/>
+          </a:xfrm>
+          <a:prstGeom prst="rect">
+            <a:avLst/>
+          </a:prstGeom>
+          <a:noFill/>
+        </p:spPr>
+        <p:txBody>
+          <a:bodyPr rot="0" spcFirstLastPara="0" vertOverflow="overflow" horzOverflow="overflow" vert="horz" wrap="square" lIns="91440" tIns="45720" rIns="91440" bIns="45720" numCol="1" spcCol="0" rtlCol="0" fromWordArt="0" anchor="t" anchorCtr="0" forceAA="0" compatLnSpc="1">
+            <a:prstTxWarp prst="textNoShape">
+              <a:avLst/>
+            </a:prstTxWarp>
+            <a:spAutoFit/>
+          </a:bodyPr>
+          <a:lstStyle/>
+          <a:p>
+            <a:pPr algn="l" rtl="0">
+              <a:lnSpc>
+                <a:spcPct val="150000"/>
+              </a:lnSpc>
+            </a:pPr>
+            <a:r>
+              <a:rPr lang="en-US" sz="2000" b="0" i="0" u="none" strike="noStrike" baseline="0" dirty="0">
+                <a:solidFill>
+                  <a:srgbClr val="000000"/>
+                </a:solidFill>
+                <a:latin typeface="Arial"/>
+              </a:rPr>
+              <a:t>Integrate IBM Cloud and </a:t>
+            </a:r>
+            <a:r>
+              <a:rPr lang="en-US" sz="2000" b="0" i="0" u="none" strike="noStrike" baseline="0" dirty="0" err="1">
+                <a:solidFill>
+                  <a:srgbClr val="000000"/>
+                </a:solidFill>
+                <a:latin typeface="Arial"/>
+              </a:rPr>
+              <a:t>AutoAI</a:t>
+            </a:r>
+            <a:r>
+              <a:rPr lang="en-US" sz="2000" b="0" i="0" u="none" strike="noStrike" baseline="0" dirty="0">
+                <a:solidFill>
+                  <a:srgbClr val="000000"/>
+                </a:solidFill>
+                <a:latin typeface="Arial"/>
+              </a:rPr>
+              <a:t> deployment securely using a .env file for API keys, deployment endpoint, project/space ID, and model credentials. Generate complete backend code, frontend templates, CSS, JavaScript, requirements.txt, .</a:t>
+            </a:r>
+            <a:r>
+              <a:rPr lang="en-US" sz="2000" b="0" i="0" u="none" strike="noStrike" baseline="0" dirty="0" err="1">
+                <a:solidFill>
+                  <a:srgbClr val="000000"/>
+                </a:solidFill>
+                <a:latin typeface="Arial"/>
+              </a:rPr>
+              <a:t>env.example</a:t>
+            </a:r>
+            <a:r>
+              <a:rPr lang="en-US" sz="2000" b="0" i="0" u="none" strike="noStrike" baseline="0" dirty="0">
+                <a:solidFill>
+                  <a:srgbClr val="000000"/>
+                </a:solidFill>
+                <a:latin typeface="Arial"/>
+              </a:rPr>
+              <a:t>, README.md, and deployment instructions.</a:t>
+            </a:r>
+            <a:r>
+              <a:rPr lang="en-US" sz="2000" b="0" i="0" dirty="0">
+                <a:latin typeface="Arial"/>
+              </a:rPr>
+              <a:t>​</a:t>
+            </a:r>
+            <a:endParaRPr lang="en-US" sz="2000" b="0" i="0">
+              <a:latin typeface="Arial"/>
+            </a:endParaRPr>
+          </a:p>
+          <a:p>
+            <a:pPr algn="l" rtl="0">
+              <a:lnSpc>
+                <a:spcPct val="150000"/>
+              </a:lnSpc>
+            </a:pPr>
+            <a:r>
+              <a:rPr lang="en-US" sz="2000" b="0" i="0">
+                <a:latin typeface="Arial"/>
+              </a:rPr>
+              <a:t>​</a:t>
+            </a:r>
+            <a:r>
+              <a:rPr lang="en-US" sz="2000" b="0" i="0" u="none" strike="noStrike" baseline="0">
+                <a:solidFill>
+                  <a:srgbClr val="000000"/>
+                </a:solidFill>
+                <a:latin typeface="Arial"/>
+              </a:rPr>
+              <a:t>Use modern UI design with Bootstrap, animations, cards, charts, dark mode, mobile responsiveness, </a:t>
+            </a:r>
+            <a:r>
+              <a:rPr lang="en-US" sz="2000" b="0" i="0" u="none" strike="noStrike" baseline="0" dirty="0">
+                <a:solidFill>
+                  <a:srgbClr val="000000"/>
+                </a:solidFill>
+                <a:latin typeface="Arial"/>
+              </a:rPr>
+              <a:t>and a clean medical theme. Add proper error handling, form validation, prediction history, and clear user-friendly explanations of the ML result.</a:t>
+            </a:r>
+            <a:r>
+              <a:rPr lang="en-US" sz="2000" b="0" i="0" dirty="0">
+                <a:latin typeface="Arial"/>
+              </a:rPr>
+              <a:t>​</a:t>
+            </a:r>
+            <a:endParaRPr lang="en-US" sz="2000" dirty="0"/>
+          </a:p>
+        </p:txBody>
+      </p:sp>
+    </p:spTree>
+    <p:extLst>
+      <p:ext uri="{BB962C8B-B14F-4D97-AF65-F5344CB8AC3E}">
+        <p14:creationId xmlns:p14="http://schemas.microsoft.com/office/powerpoint/2010/main" val="3020367746"/>
+      </p:ext>
+    </p:extLst>
+  </p:cSld>
+  <p:clrMapOvr>
+    <a:masterClrMapping/>
+  </p:clrMapOvr>
+</p:sld>
+</file>
+
+<file path=ppt/slides/slide17.xml><?xml version="1.0" encoding="utf-8"?>
+<p:sld xmlns:a="http://schemas.openxmlformats.org/drawingml/2006/main" xmlns:r="http://schemas.openxmlformats.org/officeDocument/2006/relationships" xmlns:p="http://schemas.openxmlformats.org/presentationml/2006/main">
+  <p:cSld>
+    <p:spTree>
+      <p:nvGrpSpPr>
+        <p:cNvPr id="1" name=""/>
+        <p:cNvGrpSpPr/>
+        <p:nvPr/>
+      </p:nvGrpSpPr>
+      <p:grpSpPr>
+        <a:xfrm>
+          <a:off x="0" y="0"/>
+          <a:ext cx="0" cy="0"/>
+          <a:chOff x="0" y="0"/>
+          <a:chExt cx="0" cy="0"/>
+        </a:xfrm>
+      </p:grpSpPr>
+      <p:sp>
+        <p:nvSpPr>
+          <p:cNvPr id="2" name="TextBox 1">
+            <a:extLst>
+              <a:ext uri="{FF2B5EF4-FFF2-40B4-BE49-F238E27FC236}">
+                <a16:creationId xmlns:a16="http://schemas.microsoft.com/office/drawing/2014/main" id="{677FE177-0F13-3091-36C5-84645FE63ABF}"/>
+              </a:ext>
+            </a:extLst>
+          </p:cNvPr>
+          <p:cNvSpPr txBox="1"/>
+          <p:nvPr/>
+        </p:nvSpPr>
+        <p:spPr>
+          <a:xfrm>
+            <a:off x="153608" y="170676"/>
+            <a:ext cx="11708413" cy="461665"/>
+          </a:xfrm>
+          <a:prstGeom prst="rect">
+            <a:avLst/>
+          </a:prstGeom>
+          <a:noFill/>
+        </p:spPr>
+        <p:txBody>
+          <a:bodyPr rot="0" spcFirstLastPara="0" vertOverflow="overflow" horzOverflow="overflow" vert="horz" wrap="square" lIns="91440" tIns="45720" rIns="91440" bIns="45720" numCol="1" spcCol="0" rtlCol="0" fromWordArt="0" anchor="t" anchorCtr="0" forceAA="0" compatLnSpc="1">
+            <a:prstTxWarp prst="textNoShape">
+              <a:avLst/>
+            </a:prstTxWarp>
+            <a:spAutoFit/>
+          </a:bodyPr>
+          <a:lstStyle/>
+          <a:p>
+            <a:r>
+              <a:rPr lang="en-US" sz="2400" b="1"/>
+              <a:t>IBM BOB TO-DO TASKS- </a:t>
+            </a:r>
+          </a:p>
+        </p:txBody>
+      </p:sp>
+      <p:pic>
+        <p:nvPicPr>
+          <p:cNvPr id="4" name="Picture 3" descr="A screenshot of a computer&#10;&#10;AI-generated content may be incorrect.">
+            <a:extLst>
+              <a:ext uri="{FF2B5EF4-FFF2-40B4-BE49-F238E27FC236}">
+                <a16:creationId xmlns:a16="http://schemas.microsoft.com/office/drawing/2014/main" id="{4BACCD35-B4A4-368C-AE1A-E5E60DD7418E}"/>
+              </a:ext>
+            </a:extLst>
+          </p:cNvPr>
+          <p:cNvPicPr>
+            <a:picLocks noChangeAspect="1"/>
+          </p:cNvPicPr>
+          <p:nvPr/>
+        </p:nvPicPr>
+        <p:blipFill>
+          <a:blip r:embed="rId2"/>
+          <a:stretch>
+            <a:fillRect/>
+          </a:stretch>
+        </p:blipFill>
+        <p:spPr>
+          <a:xfrm>
+            <a:off x="1240971" y="1102476"/>
+            <a:ext cx="9535886" cy="4965104"/>
+          </a:xfrm>
+          <a:prstGeom prst="rect">
+            <a:avLst/>
+          </a:prstGeom>
+        </p:spPr>
+      </p:pic>
+    </p:spTree>
+    <p:extLst>
+      <p:ext uri="{BB962C8B-B14F-4D97-AF65-F5344CB8AC3E}">
+        <p14:creationId xmlns:p14="http://schemas.microsoft.com/office/powerpoint/2010/main" val="3289104264"/>
+      </p:ext>
+    </p:extLst>
+  </p:cSld>
+  <p:clrMapOvr>
+    <a:masterClrMapping/>
+  </p:clrMapOvr>
+</p:sld>
+</file>
+
+<file path=ppt/slides/slide18.xml><?xml version="1.0" encoding="utf-8"?>
+<p:sld xmlns:a="http://schemas.openxmlformats.org/drawingml/2006/main" xmlns:r="http://schemas.openxmlformats.org/officeDocument/2006/relationships" xmlns:p="http://schemas.openxmlformats.org/presentationml/2006/main">
+  <p:cSld>
+    <p:spTree>
+      <p:nvGrpSpPr>
+        <p:cNvPr id="1" name=""/>
+        <p:cNvGrpSpPr/>
+        <p:nvPr/>
+      </p:nvGrpSpPr>
+      <p:grpSpPr>
+        <a:xfrm>
+          <a:off x="0" y="0"/>
+          <a:ext cx="0" cy="0"/>
+          <a:chOff x="0" y="0"/>
+          <a:chExt cx="0" cy="0"/>
+        </a:xfrm>
+      </p:grpSpPr>
+      <p:sp>
+        <p:nvSpPr>
+          <p:cNvPr id="2" name="TextBox 1">
+            <a:extLst>
+              <a:ext uri="{FF2B5EF4-FFF2-40B4-BE49-F238E27FC236}">
                 <a16:creationId xmlns:a16="http://schemas.microsoft.com/office/drawing/2014/main" id="{11432C6F-B55A-9A5F-016E-543AB8A203F4}"/>
               </a:ext>
             </a:extLst>
@@ -12687,7 +13123,7 @@
 </p:sld>
 </file>
 
-<file path=ppt/slides/slide16.xml><?xml version="1.0" encoding="utf-8"?>
+<file path=ppt/slides/slide19.xml><?xml version="1.0" encoding="utf-8"?>
 <p:sld xmlns:a="http://schemas.openxmlformats.org/drawingml/2006/main" xmlns:r="http://schemas.openxmlformats.org/officeDocument/2006/relationships" xmlns:p="http://schemas.openxmlformats.org/presentationml/2006/main">
   <p:cSld>
     <p:spTree>
@@ -12738,186 +13174,6 @@
     <p:extLst>
       <p:ext uri="{BB962C8B-B14F-4D97-AF65-F5344CB8AC3E}">
         <p14:creationId xmlns:p14="http://schemas.microsoft.com/office/powerpoint/2010/main" val="2037540740"/>
-      </p:ext>
-    </p:extLst>
-  </p:cSld>
-  <p:clrMapOvr>
-    <a:masterClrMapping/>
-  </p:clrMapOvr>
-</p:sld>
-</file>
-
-<file path=ppt/slides/slide17.xml><?xml version="1.0" encoding="utf-8"?>
-<p:sld xmlns:a="http://schemas.openxmlformats.org/drawingml/2006/main" xmlns:r="http://schemas.openxmlformats.org/officeDocument/2006/relationships" xmlns:p="http://schemas.openxmlformats.org/presentationml/2006/main">
-  <p:cSld>
-    <p:spTree>
-      <p:nvGrpSpPr>
-        <p:cNvPr id="1" name=""/>
-        <p:cNvGrpSpPr/>
-        <p:nvPr/>
-      </p:nvGrpSpPr>
-      <p:grpSpPr>
-        <a:xfrm>
-          <a:off x="0" y="0"/>
-          <a:ext cx="0" cy="0"/>
-          <a:chOff x="0" y="0"/>
-          <a:chExt cx="0" cy="0"/>
-        </a:xfrm>
-      </p:grpSpPr>
-      <p:pic>
-        <p:nvPicPr>
-          <p:cNvPr id="2" name="Picture 1" descr="A screenshot of a computer&#10;&#10;AI-generated content may be incorrect.">
-            <a:extLst>
-              <a:ext uri="{FF2B5EF4-FFF2-40B4-BE49-F238E27FC236}">
-                <a16:creationId xmlns:a16="http://schemas.microsoft.com/office/drawing/2014/main" id="{99D9DBAE-B2FC-0264-40CB-97485E9B0380}"/>
-              </a:ext>
-            </a:extLst>
-          </p:cNvPr>
-          <p:cNvPicPr>
-            <a:picLocks noChangeAspect="1"/>
-          </p:cNvPicPr>
-          <p:nvPr/>
-        </p:nvPicPr>
-        <p:blipFill>
-          <a:blip r:embed="rId2"/>
-          <a:stretch>
-            <a:fillRect/>
-          </a:stretch>
-        </p:blipFill>
-        <p:spPr>
-          <a:xfrm>
-            <a:off x="486228" y="1011645"/>
-            <a:ext cx="11219543" cy="4515395"/>
-          </a:xfrm>
-          <a:prstGeom prst="rect">
-            <a:avLst/>
-          </a:prstGeom>
-        </p:spPr>
-      </p:pic>
-    </p:spTree>
-    <p:extLst>
-      <p:ext uri="{BB962C8B-B14F-4D97-AF65-F5344CB8AC3E}">
-        <p14:creationId xmlns:p14="http://schemas.microsoft.com/office/powerpoint/2010/main" val="3955666782"/>
-      </p:ext>
-    </p:extLst>
-  </p:cSld>
-  <p:clrMapOvr>
-    <a:masterClrMapping/>
-  </p:clrMapOvr>
-</p:sld>
-</file>
-
-<file path=ppt/slides/slide18.xml><?xml version="1.0" encoding="utf-8"?>
-<p:sld xmlns:a="http://schemas.openxmlformats.org/drawingml/2006/main" xmlns:r="http://schemas.openxmlformats.org/officeDocument/2006/relationships" xmlns:p="http://schemas.openxmlformats.org/presentationml/2006/main">
-  <p:cSld>
-    <p:spTree>
-      <p:nvGrpSpPr>
-        <p:cNvPr id="1" name=""/>
-        <p:cNvGrpSpPr/>
-        <p:nvPr/>
-      </p:nvGrpSpPr>
-      <p:grpSpPr>
-        <a:xfrm>
-          <a:off x="0" y="0"/>
-          <a:ext cx="0" cy="0"/>
-          <a:chOff x="0" y="0"/>
-          <a:chExt cx="0" cy="0"/>
-        </a:xfrm>
-      </p:grpSpPr>
-      <p:pic>
-        <p:nvPicPr>
-          <p:cNvPr id="2" name="Picture 1" descr="A screenshot of a video game&#10;&#10;AI-generated content may be incorrect.">
-            <a:extLst>
-              <a:ext uri="{FF2B5EF4-FFF2-40B4-BE49-F238E27FC236}">
-                <a16:creationId xmlns:a16="http://schemas.microsoft.com/office/drawing/2014/main" id="{29ECAED8-ECBA-2642-53FF-5856E75D10E9}"/>
-              </a:ext>
-            </a:extLst>
-          </p:cNvPr>
-          <p:cNvPicPr>
-            <a:picLocks noChangeAspect="1"/>
-          </p:cNvPicPr>
-          <p:nvPr/>
-        </p:nvPicPr>
-        <p:blipFill>
-          <a:blip r:embed="rId2"/>
-          <a:stretch>
-            <a:fillRect/>
-          </a:stretch>
-        </p:blipFill>
-        <p:spPr>
-          <a:xfrm>
-            <a:off x="457200" y="1000578"/>
-            <a:ext cx="11277600" cy="4544786"/>
-          </a:xfrm>
-          <a:prstGeom prst="rect">
-            <a:avLst/>
-          </a:prstGeom>
-        </p:spPr>
-      </p:pic>
-    </p:spTree>
-    <p:extLst>
-      <p:ext uri="{BB962C8B-B14F-4D97-AF65-F5344CB8AC3E}">
-        <p14:creationId xmlns:p14="http://schemas.microsoft.com/office/powerpoint/2010/main" val="1509127637"/>
-      </p:ext>
-    </p:extLst>
-  </p:cSld>
-  <p:clrMapOvr>
-    <a:masterClrMapping/>
-  </p:clrMapOvr>
-</p:sld>
-</file>
-
-<file path=ppt/slides/slide19.xml><?xml version="1.0" encoding="utf-8"?>
-<p:sld xmlns:a="http://schemas.openxmlformats.org/drawingml/2006/main" xmlns:r="http://schemas.openxmlformats.org/officeDocument/2006/relationships" xmlns:p="http://schemas.openxmlformats.org/presentationml/2006/main">
-  <p:cSld>
-    <p:spTree>
-      <p:nvGrpSpPr>
-        <p:cNvPr id="1" name=""/>
-        <p:cNvGrpSpPr/>
-        <p:nvPr/>
-      </p:nvGrpSpPr>
-      <p:grpSpPr>
-        <a:xfrm>
-          <a:off x="0" y="0"/>
-          <a:ext cx="0" cy="0"/>
-          <a:chOff x="0" y="0"/>
-          <a:chExt cx="0" cy="0"/>
-        </a:xfrm>
-      </p:grpSpPr>
-      <p:pic>
-        <p:nvPicPr>
-          <p:cNvPr id="2" name="Picture 1" descr="A screenshot of a computer&#10;&#10;AI-generated content may be incorrect.">
-            <a:extLst>
-              <a:ext uri="{FF2B5EF4-FFF2-40B4-BE49-F238E27FC236}">
-                <a16:creationId xmlns:a16="http://schemas.microsoft.com/office/drawing/2014/main" id="{F85B37C1-F390-4BC1-EED6-9975372840E5}"/>
-              </a:ext>
-            </a:extLst>
-          </p:cNvPr>
-          <p:cNvPicPr>
-            <a:picLocks noChangeAspect="1"/>
-          </p:cNvPicPr>
-          <p:nvPr/>
-        </p:nvPicPr>
-        <p:blipFill>
-          <a:blip r:embed="rId2"/>
-          <a:stretch>
-            <a:fillRect/>
-          </a:stretch>
-        </p:blipFill>
-        <p:spPr>
-          <a:xfrm>
-            <a:off x="384628" y="993321"/>
-            <a:ext cx="11422743" cy="4602843"/>
-          </a:xfrm>
-          <a:prstGeom prst="rect">
-            <a:avLst/>
-          </a:prstGeom>
-        </p:spPr>
-      </p:pic>
-    </p:spTree>
-    <p:extLst>
-      <p:ext uri="{BB962C8B-B14F-4D97-AF65-F5344CB8AC3E}">
-        <p14:creationId xmlns:p14="http://schemas.microsoft.com/office/powerpoint/2010/main" val="663858326"/>
       </p:ext>
     </p:extLst>
   </p:cSld>
@@ -13877,6 +14133,186 @@
       </p:grpSpPr>
       <p:pic>
         <p:nvPicPr>
+          <p:cNvPr id="2" name="Picture 1" descr="A screenshot of a computer&#10;&#10;AI-generated content may be incorrect.">
+            <a:extLst>
+              <a:ext uri="{FF2B5EF4-FFF2-40B4-BE49-F238E27FC236}">
+                <a16:creationId xmlns:a16="http://schemas.microsoft.com/office/drawing/2014/main" id="{99D9DBAE-B2FC-0264-40CB-97485E9B0380}"/>
+              </a:ext>
+            </a:extLst>
+          </p:cNvPr>
+          <p:cNvPicPr>
+            <a:picLocks noChangeAspect="1"/>
+          </p:cNvPicPr>
+          <p:nvPr/>
+        </p:nvPicPr>
+        <p:blipFill>
+          <a:blip r:embed="rId2"/>
+          <a:stretch>
+            <a:fillRect/>
+          </a:stretch>
+        </p:blipFill>
+        <p:spPr>
+          <a:xfrm>
+            <a:off x="486228" y="1011645"/>
+            <a:ext cx="11219543" cy="4515395"/>
+          </a:xfrm>
+          <a:prstGeom prst="rect">
+            <a:avLst/>
+          </a:prstGeom>
+        </p:spPr>
+      </p:pic>
+    </p:spTree>
+    <p:extLst>
+      <p:ext uri="{BB962C8B-B14F-4D97-AF65-F5344CB8AC3E}">
+        <p14:creationId xmlns:p14="http://schemas.microsoft.com/office/powerpoint/2010/main" val="3955666782"/>
+      </p:ext>
+    </p:extLst>
+  </p:cSld>
+  <p:clrMapOvr>
+    <a:masterClrMapping/>
+  </p:clrMapOvr>
+</p:sld>
+</file>
+
+<file path=ppt/slides/slide21.xml><?xml version="1.0" encoding="utf-8"?>
+<p:sld xmlns:a="http://schemas.openxmlformats.org/drawingml/2006/main" xmlns:r="http://schemas.openxmlformats.org/officeDocument/2006/relationships" xmlns:p="http://schemas.openxmlformats.org/presentationml/2006/main">
+  <p:cSld>
+    <p:spTree>
+      <p:nvGrpSpPr>
+        <p:cNvPr id="1" name=""/>
+        <p:cNvGrpSpPr/>
+        <p:nvPr/>
+      </p:nvGrpSpPr>
+      <p:grpSpPr>
+        <a:xfrm>
+          <a:off x="0" y="0"/>
+          <a:ext cx="0" cy="0"/>
+          <a:chOff x="0" y="0"/>
+          <a:chExt cx="0" cy="0"/>
+        </a:xfrm>
+      </p:grpSpPr>
+      <p:pic>
+        <p:nvPicPr>
+          <p:cNvPr id="2" name="Picture 1" descr="A screenshot of a video game&#10;&#10;AI-generated content may be incorrect.">
+            <a:extLst>
+              <a:ext uri="{FF2B5EF4-FFF2-40B4-BE49-F238E27FC236}">
+                <a16:creationId xmlns:a16="http://schemas.microsoft.com/office/drawing/2014/main" id="{29ECAED8-ECBA-2642-53FF-5856E75D10E9}"/>
+              </a:ext>
+            </a:extLst>
+          </p:cNvPr>
+          <p:cNvPicPr>
+            <a:picLocks noChangeAspect="1"/>
+          </p:cNvPicPr>
+          <p:nvPr/>
+        </p:nvPicPr>
+        <p:blipFill>
+          <a:blip r:embed="rId2"/>
+          <a:stretch>
+            <a:fillRect/>
+          </a:stretch>
+        </p:blipFill>
+        <p:spPr>
+          <a:xfrm>
+            <a:off x="457200" y="1000578"/>
+            <a:ext cx="11277600" cy="4544786"/>
+          </a:xfrm>
+          <a:prstGeom prst="rect">
+            <a:avLst/>
+          </a:prstGeom>
+        </p:spPr>
+      </p:pic>
+    </p:spTree>
+    <p:extLst>
+      <p:ext uri="{BB962C8B-B14F-4D97-AF65-F5344CB8AC3E}">
+        <p14:creationId xmlns:p14="http://schemas.microsoft.com/office/powerpoint/2010/main" val="1509127637"/>
+      </p:ext>
+    </p:extLst>
+  </p:cSld>
+  <p:clrMapOvr>
+    <a:masterClrMapping/>
+  </p:clrMapOvr>
+</p:sld>
+</file>
+
+<file path=ppt/slides/slide22.xml><?xml version="1.0" encoding="utf-8"?>
+<p:sld xmlns:a="http://schemas.openxmlformats.org/drawingml/2006/main" xmlns:r="http://schemas.openxmlformats.org/officeDocument/2006/relationships" xmlns:p="http://schemas.openxmlformats.org/presentationml/2006/main">
+  <p:cSld>
+    <p:spTree>
+      <p:nvGrpSpPr>
+        <p:cNvPr id="1" name=""/>
+        <p:cNvGrpSpPr/>
+        <p:nvPr/>
+      </p:nvGrpSpPr>
+      <p:grpSpPr>
+        <a:xfrm>
+          <a:off x="0" y="0"/>
+          <a:ext cx="0" cy="0"/>
+          <a:chOff x="0" y="0"/>
+          <a:chExt cx="0" cy="0"/>
+        </a:xfrm>
+      </p:grpSpPr>
+      <p:pic>
+        <p:nvPicPr>
+          <p:cNvPr id="2" name="Picture 1" descr="A screenshot of a computer&#10;&#10;AI-generated content may be incorrect.">
+            <a:extLst>
+              <a:ext uri="{FF2B5EF4-FFF2-40B4-BE49-F238E27FC236}">
+                <a16:creationId xmlns:a16="http://schemas.microsoft.com/office/drawing/2014/main" id="{F85B37C1-F390-4BC1-EED6-9975372840E5}"/>
+              </a:ext>
+            </a:extLst>
+          </p:cNvPr>
+          <p:cNvPicPr>
+            <a:picLocks noChangeAspect="1"/>
+          </p:cNvPicPr>
+          <p:nvPr/>
+        </p:nvPicPr>
+        <p:blipFill>
+          <a:blip r:embed="rId2"/>
+          <a:stretch>
+            <a:fillRect/>
+          </a:stretch>
+        </p:blipFill>
+        <p:spPr>
+          <a:xfrm>
+            <a:off x="384628" y="993321"/>
+            <a:ext cx="11422743" cy="4602843"/>
+          </a:xfrm>
+          <a:prstGeom prst="rect">
+            <a:avLst/>
+          </a:prstGeom>
+        </p:spPr>
+      </p:pic>
+    </p:spTree>
+    <p:extLst>
+      <p:ext uri="{BB962C8B-B14F-4D97-AF65-F5344CB8AC3E}">
+        <p14:creationId xmlns:p14="http://schemas.microsoft.com/office/powerpoint/2010/main" val="663858326"/>
+      </p:ext>
+    </p:extLst>
+  </p:cSld>
+  <p:clrMapOvr>
+    <a:masterClrMapping/>
+  </p:clrMapOvr>
+</p:sld>
+</file>
+
+<file path=ppt/slides/slide23.xml><?xml version="1.0" encoding="utf-8"?>
+<p:sld xmlns:a="http://schemas.openxmlformats.org/drawingml/2006/main" xmlns:r="http://schemas.openxmlformats.org/officeDocument/2006/relationships" xmlns:p="http://schemas.openxmlformats.org/presentationml/2006/main">
+  <p:cSld>
+    <p:spTree>
+      <p:nvGrpSpPr>
+        <p:cNvPr id="1" name=""/>
+        <p:cNvGrpSpPr/>
+        <p:nvPr/>
+      </p:nvGrpSpPr>
+      <p:grpSpPr>
+        <a:xfrm>
+          <a:off x="0" y="0"/>
+          <a:ext cx="0" cy="0"/>
+          <a:chOff x="0" y="0"/>
+          <a:chExt cx="0" cy="0"/>
+        </a:xfrm>
+      </p:grpSpPr>
+      <p:pic>
+        <p:nvPicPr>
           <p:cNvPr id="2" name="Picture 1" descr="A screenshot of a medical information&#10;&#10;AI-generated content may be incorrect.">
             <a:extLst>
               <a:ext uri="{FF2B5EF4-FFF2-40B4-BE49-F238E27FC236}">
@@ -13918,7 +14354,7 @@
 </p:sld>
 </file>
 
-<file path=ppt/slides/slide21.xml><?xml version="1.0" encoding="utf-8"?>
+<file path=ppt/slides/slide24.xml><?xml version="1.0" encoding="utf-8"?>
 <p:sld xmlns:a="http://schemas.openxmlformats.org/drawingml/2006/main" xmlns:r="http://schemas.openxmlformats.org/officeDocument/2006/relationships" xmlns:p="http://schemas.openxmlformats.org/presentationml/2006/main">
   <p:cSld>
     <p:spTree>
@@ -13978,7 +14414,7 @@
 </p:sld>
 </file>
 
-<file path=ppt/slides/slide22.xml><?xml version="1.0" encoding="utf-8"?>
+<file path=ppt/slides/slide25.xml><?xml version="1.0" encoding="utf-8"?>
 <p:sld xmlns:a="http://schemas.openxmlformats.org/drawingml/2006/main" xmlns:r="http://schemas.openxmlformats.org/officeDocument/2006/relationships" xmlns:p="http://schemas.openxmlformats.org/presentationml/2006/main">
   <p:cSld>
     <p:spTree>
@@ -14038,7 +14474,7 @@
 </p:sld>
 </file>
 
-<file path=ppt/slides/slide23.xml><?xml version="1.0" encoding="utf-8"?>
+<file path=ppt/slides/slide26.xml><?xml version="1.0" encoding="utf-8"?>
 <p:sld xmlns:a="http://schemas.openxmlformats.org/drawingml/2006/main" xmlns:r="http://schemas.openxmlformats.org/officeDocument/2006/relationships" xmlns:p="http://schemas.openxmlformats.org/presentationml/2006/main">
   <p:cSld>
     <p:spTree>
@@ -14098,7 +14534,7 @@
 </p:sld>
 </file>
 
-<file path=ppt/slides/slide24.xml><?xml version="1.0" encoding="utf-8"?>
+<file path=ppt/slides/slide27.xml><?xml version="1.0" encoding="utf-8"?>
 <p:sld xmlns:a="http://schemas.openxmlformats.org/drawingml/2006/main" xmlns:r="http://schemas.openxmlformats.org/officeDocument/2006/relationships" xmlns:p="http://schemas.openxmlformats.org/presentationml/2006/main">
   <p:cSld>
     <p:spTree>
@@ -14158,7 +14594,7 @@
 </p:sld>
 </file>
 
-<file path=ppt/slides/slide25.xml><?xml version="1.0" encoding="utf-8"?>
+<file path=ppt/slides/slide28.xml><?xml version="1.0" encoding="utf-8"?>
 <p:sld xmlns:a="http://schemas.openxmlformats.org/drawingml/2006/main" xmlns:r="http://schemas.openxmlformats.org/officeDocument/2006/relationships" xmlns:p="http://schemas.openxmlformats.org/presentationml/2006/main">
   <p:cSld>
     <p:spTree>
@@ -14256,7 +14692,7 @@
 </p:sld>
 </file>
 
-<file path=ppt/slides/slide26.xml><?xml version="1.0" encoding="utf-8"?>
+<file path=ppt/slides/slide29.xml><?xml version="1.0" encoding="utf-8"?>
 <p:sld xmlns:a="http://schemas.openxmlformats.org/drawingml/2006/main" xmlns:r="http://schemas.openxmlformats.org/officeDocument/2006/relationships" xmlns:p="http://schemas.openxmlformats.org/presentationml/2006/main">
   <p:cSld>
     <p:spTree>
@@ -14513,1110 +14949,6 @@
     <p:extLst>
       <p:ext uri="{BB962C8B-B14F-4D97-AF65-F5344CB8AC3E}">
         <p14:creationId xmlns:p14="http://schemas.microsoft.com/office/powerpoint/2010/main" val="917964102"/>
-      </p:ext>
-    </p:extLst>
-  </p:cSld>
-  <p:clrMapOvr>
-    <a:masterClrMapping/>
-  </p:clrMapOvr>
-</p:sld>
-</file>
-
-<file path=ppt/slides/slide27.xml><?xml version="1.0" encoding="utf-8"?>
-<p:sld xmlns:a="http://schemas.openxmlformats.org/drawingml/2006/main" xmlns:r="http://schemas.openxmlformats.org/officeDocument/2006/relationships" xmlns:p="http://schemas.openxmlformats.org/presentationml/2006/main">
-  <p:cSld>
-    <p:spTree>
-      <p:nvGrpSpPr>
-        <p:cNvPr id="1" name="Shape 274">
-          <a:extLst>
-            <a:ext uri="{FF2B5EF4-FFF2-40B4-BE49-F238E27FC236}">
-              <a16:creationId xmlns:a16="http://schemas.microsoft.com/office/drawing/2014/main" id="{7BB3C0CA-2F24-30DF-1D65-4440B864F08E}"/>
-            </a:ext>
-          </a:extLst>
-        </p:cNvPr>
-        <p:cNvGrpSpPr/>
-        <p:nvPr/>
-      </p:nvGrpSpPr>
-      <p:grpSpPr>
-        <a:xfrm>
-          <a:off x="0" y="0"/>
-          <a:ext cx="0" cy="0"/>
-          <a:chOff x="0" y="0"/>
-          <a:chExt cx="0" cy="0"/>
-        </a:xfrm>
-      </p:grpSpPr>
-      <p:sp>
-        <p:nvSpPr>
-          <p:cNvPr id="278" name="Google Shape;278;p18">
-            <a:extLst>
-              <a:ext uri="{FF2B5EF4-FFF2-40B4-BE49-F238E27FC236}">
-                <a16:creationId xmlns:a16="http://schemas.microsoft.com/office/drawing/2014/main" id="{187EEB9C-2E84-113A-3CE6-1507BF5B039F}"/>
-              </a:ext>
-            </a:extLst>
-          </p:cNvPr>
-          <p:cNvSpPr/>
-          <p:nvPr/>
-        </p:nvSpPr>
-        <p:spPr>
-          <a:xfrm>
-            <a:off x="1218724" y="420729"/>
-            <a:ext cx="6444496" cy="704017"/>
-          </a:xfrm>
-          <a:prstGeom prst="rect">
-            <a:avLst/>
-          </a:prstGeom>
-          <a:noFill/>
-          <a:ln>
-            <a:noFill/>
-          </a:ln>
-        </p:spPr>
-        <p:txBody>
-          <a:bodyPr spcFirstLastPara="1" wrap="square" lIns="0" tIns="0" rIns="0" bIns="0" anchor="t" anchorCtr="0">
-            <a:noAutofit/>
-          </a:bodyPr>
-          <a:lstStyle/>
-          <a:p>
-            <a:pPr marL="0" marR="0" lvl="0" indent="0" algn="l" rtl="0">
-              <a:lnSpc>
-                <a:spcPct val="157142"/>
-              </a:lnSpc>
-              <a:spcBef>
-                <a:spcPts val="0"/>
-              </a:spcBef>
-              <a:spcAft>
-                <a:spcPts val="0"/>
-              </a:spcAft>
-              <a:buClr>
-                <a:srgbClr val="051D3A"/>
-              </a:buClr>
-              <a:buSzPts val="3500"/>
-              <a:buFont typeface="Times New Roman"/>
-              <a:buNone/>
-            </a:pPr>
-            <a:r>
-              <a:rPr lang="en-US" sz="2400" b="1">
-                <a:sym typeface="Times New Roman"/>
-              </a:rPr>
-              <a:t>Git Hub Link</a:t>
-            </a:r>
-            <a:endParaRPr sz="2400" b="1">
-              <a:sym typeface="Times New Roman"/>
-            </a:endParaRPr>
-          </a:p>
-        </p:txBody>
-      </p:sp>
-      <p:sp>
-        <p:nvSpPr>
-          <p:cNvPr id="279" name="Google Shape;279;p18">
-            <a:extLst>
-              <a:ext uri="{FF2B5EF4-FFF2-40B4-BE49-F238E27FC236}">
-                <a16:creationId xmlns:a16="http://schemas.microsoft.com/office/drawing/2014/main" id="{3711AF54-94A6-B837-31EF-9A8C4ECB9AF6}"/>
-              </a:ext>
-            </a:extLst>
-          </p:cNvPr>
-          <p:cNvSpPr/>
-          <p:nvPr/>
-        </p:nvSpPr>
-        <p:spPr>
-          <a:xfrm>
-            <a:off x="1218724" y="1153712"/>
-            <a:ext cx="9214580" cy="4277001"/>
-          </a:xfrm>
-          <a:prstGeom prst="rect">
-            <a:avLst/>
-          </a:prstGeom>
-          <a:noFill/>
-          <a:ln>
-            <a:noFill/>
-          </a:ln>
-        </p:spPr>
-        <p:txBody>
-          <a:bodyPr spcFirstLastPara="1" wrap="square" lIns="0" tIns="0" rIns="0" bIns="0" anchor="t" anchorCtr="0">
-            <a:noAutofit/>
-          </a:bodyPr>
-          <a:lstStyle/>
-          <a:p>
-            <a:pPr marL="0" marR="0" lvl="0" indent="0" algn="l">
-              <a:lnSpc>
-                <a:spcPct val="162162"/>
-              </a:lnSpc>
-              <a:spcBef>
-                <a:spcPts val="0"/>
-              </a:spcBef>
-              <a:spcAft>
-                <a:spcPts val="0"/>
-              </a:spcAft>
-              <a:buNone/>
-            </a:pPr>
-            <a:r>
-              <a:rPr lang="en-US" sz="1850" dirty="0">
-                <a:hlinkClick r:id="rId3"/>
-              </a:rPr>
-              <a:t>https://github.com/lakshmisatwika28-lang/Breast-Cancer-Prediction-AutoAI.git</a:t>
-            </a:r>
-            <a:endParaRPr lang="en-US"/>
-          </a:p>
-        </p:txBody>
-      </p:sp>
-      <p:sp>
-        <p:nvSpPr>
-          <p:cNvPr id="280" name="Google Shape;280;p18">
-            <a:extLst>
-              <a:ext uri="{FF2B5EF4-FFF2-40B4-BE49-F238E27FC236}">
-                <a16:creationId xmlns:a16="http://schemas.microsoft.com/office/drawing/2014/main" id="{E228982D-BF81-530A-CBA1-E897A3CA8EF7}"/>
-              </a:ext>
-            </a:extLst>
-          </p:cNvPr>
-          <p:cNvSpPr/>
-          <p:nvPr/>
-        </p:nvSpPr>
-        <p:spPr>
-          <a:xfrm>
-            <a:off x="1218724" y="3360216"/>
-            <a:ext cx="7468553" cy="766048"/>
-          </a:xfrm>
-          <a:prstGeom prst="rect">
-            <a:avLst/>
-          </a:prstGeom>
-          <a:noFill/>
-          <a:ln>
-            <a:noFill/>
-          </a:ln>
-        </p:spPr>
-        <p:txBody>
-          <a:bodyPr spcFirstLastPara="1" wrap="square" lIns="0" tIns="0" rIns="0" bIns="0" anchor="t" anchorCtr="0">
-            <a:noAutofit/>
-          </a:bodyPr>
-          <a:lstStyle/>
-          <a:p>
-            <a:pPr marL="0" marR="0" lvl="0" indent="0" algn="l" rtl="0">
-              <a:lnSpc>
-                <a:spcPct val="162162"/>
-              </a:lnSpc>
-              <a:spcBef>
-                <a:spcPts val="0"/>
-              </a:spcBef>
-              <a:spcAft>
-                <a:spcPts val="0"/>
-              </a:spcAft>
-              <a:buClr>
-                <a:srgbClr val="2B3541"/>
-              </a:buClr>
-              <a:buSzPts val="1850"/>
-              <a:buFont typeface="Times New Roman"/>
-              <a:buNone/>
-            </a:pPr>
-            <a:r>
-              <a:rPr lang="en-US" sz="1850" b="0" i="0" u="none" strike="noStrike" cap="none">
-                <a:solidFill>
-                  <a:srgbClr val="2B3541"/>
-                </a:solidFill>
-                <a:latin typeface="Times New Roman"/>
-                <a:ea typeface="Times New Roman"/>
-                <a:cs typeface="Times New Roman"/>
-                <a:sym typeface="Times New Roman"/>
-              </a:rPr>
-              <a:t>·</a:t>
-            </a:r>
-            <a:endParaRPr sz="1850" b="0" i="0" u="none" strike="noStrike" cap="none">
-              <a:solidFill>
-                <a:srgbClr val="000000"/>
-              </a:solidFill>
-              <a:latin typeface="Times New Roman"/>
-              <a:ea typeface="Times New Roman"/>
-              <a:cs typeface="Times New Roman"/>
-              <a:sym typeface="Times New Roman"/>
-            </a:endParaRPr>
-          </a:p>
-        </p:txBody>
-      </p:sp>
-      <p:sp>
-        <p:nvSpPr>
-          <p:cNvPr id="281" name="Google Shape;281;p18">
-            <a:extLst>
-              <a:ext uri="{FF2B5EF4-FFF2-40B4-BE49-F238E27FC236}">
-                <a16:creationId xmlns:a16="http://schemas.microsoft.com/office/drawing/2014/main" id="{7BC356B8-92F8-3187-D065-667AACF68E72}"/>
-              </a:ext>
-            </a:extLst>
-          </p:cNvPr>
-          <p:cNvSpPr/>
-          <p:nvPr/>
-        </p:nvSpPr>
-        <p:spPr>
-          <a:xfrm>
-            <a:off x="1218724" y="4395464"/>
-            <a:ext cx="7468553" cy="766048"/>
-          </a:xfrm>
-          <a:prstGeom prst="rect">
-            <a:avLst/>
-          </a:prstGeom>
-          <a:noFill/>
-          <a:ln>
-            <a:noFill/>
-          </a:ln>
-        </p:spPr>
-        <p:txBody>
-          <a:bodyPr spcFirstLastPara="1" wrap="square" lIns="0" tIns="0" rIns="0" bIns="0" anchor="t" anchorCtr="0">
-            <a:noAutofit/>
-          </a:bodyPr>
-          <a:lstStyle/>
-          <a:p>
-            <a:pPr marL="0" marR="0" lvl="0" indent="0" algn="l" rtl="0">
-              <a:lnSpc>
-                <a:spcPct val="162162"/>
-              </a:lnSpc>
-              <a:spcBef>
-                <a:spcPts val="0"/>
-              </a:spcBef>
-              <a:spcAft>
-                <a:spcPts val="0"/>
-              </a:spcAft>
-              <a:buClr>
-                <a:srgbClr val="2B3541"/>
-              </a:buClr>
-              <a:buSzPts val="1850"/>
-              <a:buFont typeface="Times New Roman"/>
-              <a:buNone/>
-            </a:pPr>
-            <a:r>
-              <a:rPr lang="en-US" sz="1850" b="0" i="0" u="none" strike="noStrike" cap="none">
-                <a:solidFill>
-                  <a:srgbClr val="2B3541"/>
-                </a:solidFill>
-                <a:latin typeface="Times New Roman"/>
-                <a:ea typeface="Times New Roman"/>
-                <a:cs typeface="Times New Roman"/>
-                <a:sym typeface="Times New Roman"/>
-              </a:rPr>
-              <a:t>·</a:t>
-            </a:r>
-            <a:endParaRPr sz="1850" b="0" i="0" u="none" strike="noStrike" cap="none">
-              <a:solidFill>
-                <a:srgbClr val="000000"/>
-              </a:solidFill>
-              <a:latin typeface="Times New Roman"/>
-              <a:ea typeface="Times New Roman"/>
-              <a:cs typeface="Times New Roman"/>
-              <a:sym typeface="Times New Roman"/>
-            </a:endParaRPr>
-          </a:p>
-        </p:txBody>
-      </p:sp>
-      <p:sp>
-        <p:nvSpPr>
-          <p:cNvPr id="282" name="Google Shape;282;p18">
-            <a:extLst>
-              <a:ext uri="{FF2B5EF4-FFF2-40B4-BE49-F238E27FC236}">
-                <a16:creationId xmlns:a16="http://schemas.microsoft.com/office/drawing/2014/main" id="{1558A011-60D6-B010-6117-1B9F7C786B2B}"/>
-              </a:ext>
-            </a:extLst>
-          </p:cNvPr>
-          <p:cNvSpPr/>
-          <p:nvPr/>
-        </p:nvSpPr>
-        <p:spPr>
-          <a:xfrm>
-            <a:off x="1218724" y="5430713"/>
-            <a:ext cx="7468553" cy="383024"/>
-          </a:xfrm>
-          <a:prstGeom prst="rect">
-            <a:avLst/>
-          </a:prstGeom>
-          <a:noFill/>
-          <a:ln>
-            <a:noFill/>
-          </a:ln>
-        </p:spPr>
-        <p:txBody>
-          <a:bodyPr spcFirstLastPara="1" wrap="square" lIns="0" tIns="0" rIns="0" bIns="0" anchor="t" anchorCtr="0">
-            <a:noAutofit/>
-          </a:bodyPr>
-          <a:lstStyle/>
-          <a:p>
-            <a:pPr marL="0" marR="0" lvl="0" indent="0" algn="l" rtl="0">
-              <a:lnSpc>
-                <a:spcPct val="162162"/>
-              </a:lnSpc>
-              <a:spcBef>
-                <a:spcPts val="0"/>
-              </a:spcBef>
-              <a:spcAft>
-                <a:spcPts val="0"/>
-              </a:spcAft>
-              <a:buClr>
-                <a:srgbClr val="2B3541"/>
-              </a:buClr>
-              <a:buSzPts val="1850"/>
-              <a:buFont typeface="Times New Roman"/>
-              <a:buNone/>
-            </a:pPr>
-            <a:r>
-              <a:rPr lang="en-US" sz="1850" b="0" i="0" u="none" strike="noStrike" cap="none">
-                <a:solidFill>
-                  <a:srgbClr val="2B3541"/>
-                </a:solidFill>
-                <a:latin typeface="Times New Roman"/>
-                <a:ea typeface="Times New Roman"/>
-                <a:cs typeface="Times New Roman"/>
-                <a:sym typeface="Times New Roman"/>
-              </a:rPr>
-              <a:t>·</a:t>
-            </a:r>
-            <a:endParaRPr sz="1850" b="0" i="0" u="none" strike="noStrike" cap="none">
-              <a:solidFill>
-                <a:srgbClr val="000000"/>
-              </a:solidFill>
-              <a:latin typeface="Times New Roman"/>
-              <a:ea typeface="Times New Roman"/>
-              <a:cs typeface="Times New Roman"/>
-              <a:sym typeface="Times New Roman"/>
-            </a:endParaRPr>
-          </a:p>
-        </p:txBody>
-      </p:sp>
-    </p:spTree>
-    <p:extLst>
-      <p:ext uri="{BB962C8B-B14F-4D97-AF65-F5344CB8AC3E}">
-        <p14:creationId xmlns:p14="http://schemas.microsoft.com/office/powerpoint/2010/main" val="2605851928"/>
-      </p:ext>
-    </p:extLst>
-  </p:cSld>
-  <p:clrMapOvr>
-    <a:masterClrMapping/>
-  </p:clrMapOvr>
-</p:sld>
-</file>
-
-<file path=ppt/slides/slide28.xml><?xml version="1.0" encoding="utf-8"?>
-<p:sld xmlns:a="http://schemas.openxmlformats.org/drawingml/2006/main" xmlns:r="http://schemas.openxmlformats.org/officeDocument/2006/relationships" xmlns:p="http://schemas.openxmlformats.org/presentationml/2006/main">
-  <p:cSld>
-    <p:spTree>
-      <p:nvGrpSpPr>
-        <p:cNvPr id="1" name="Shape 274">
-          <a:extLst>
-            <a:ext uri="{FF2B5EF4-FFF2-40B4-BE49-F238E27FC236}">
-              <a16:creationId xmlns:a16="http://schemas.microsoft.com/office/drawing/2014/main" id="{6FA0F82B-7EE5-EAB0-F470-130BDAC8254B}"/>
-            </a:ext>
-          </a:extLst>
-        </p:cNvPr>
-        <p:cNvGrpSpPr/>
-        <p:nvPr/>
-      </p:nvGrpSpPr>
-      <p:grpSpPr>
-        <a:xfrm>
-          <a:off x="0" y="0"/>
-          <a:ext cx="0" cy="0"/>
-          <a:chOff x="0" y="0"/>
-          <a:chExt cx="0" cy="0"/>
-        </a:xfrm>
-      </p:grpSpPr>
-      <p:sp>
-        <p:nvSpPr>
-          <p:cNvPr id="278" name="Google Shape;278;p18">
-            <a:extLst>
-              <a:ext uri="{FF2B5EF4-FFF2-40B4-BE49-F238E27FC236}">
-                <a16:creationId xmlns:a16="http://schemas.microsoft.com/office/drawing/2014/main" id="{0668C6FD-577A-7288-5642-1AFC22BD04F2}"/>
-              </a:ext>
-            </a:extLst>
-          </p:cNvPr>
-          <p:cNvSpPr/>
-          <p:nvPr/>
-        </p:nvSpPr>
-        <p:spPr>
-          <a:xfrm>
-            <a:off x="1218724" y="420729"/>
-            <a:ext cx="6444496" cy="704017"/>
-          </a:xfrm>
-          <a:prstGeom prst="rect">
-            <a:avLst/>
-          </a:prstGeom>
-          <a:noFill/>
-          <a:ln>
-            <a:noFill/>
-          </a:ln>
-        </p:spPr>
-        <p:txBody>
-          <a:bodyPr spcFirstLastPara="1" wrap="square" lIns="0" tIns="0" rIns="0" bIns="0" anchor="t" anchorCtr="0">
-            <a:noAutofit/>
-          </a:bodyPr>
-          <a:lstStyle/>
-          <a:p>
-            <a:pPr marL="0" marR="0" lvl="0" indent="0" algn="l" rtl="0">
-              <a:lnSpc>
-                <a:spcPct val="157142"/>
-              </a:lnSpc>
-              <a:spcBef>
-                <a:spcPts val="0"/>
-              </a:spcBef>
-              <a:spcAft>
-                <a:spcPts val="0"/>
-              </a:spcAft>
-              <a:buClr>
-                <a:srgbClr val="051D3A"/>
-              </a:buClr>
-              <a:buSzPts val="3500"/>
-              <a:buFont typeface="Times New Roman"/>
-              <a:buNone/>
-            </a:pPr>
-            <a:r>
-              <a:rPr lang="en-US" sz="2400" b="1">
-                <a:sym typeface="Times New Roman"/>
-              </a:rPr>
-              <a:t>Future Scope </a:t>
-            </a:r>
-            <a:endParaRPr sz="2400" b="1">
-              <a:sym typeface="Times New Roman"/>
-            </a:endParaRPr>
-          </a:p>
-        </p:txBody>
-      </p:sp>
-      <p:sp>
-        <p:nvSpPr>
-          <p:cNvPr id="279" name="Google Shape;279;p18">
-            <a:extLst>
-              <a:ext uri="{FF2B5EF4-FFF2-40B4-BE49-F238E27FC236}">
-                <a16:creationId xmlns:a16="http://schemas.microsoft.com/office/drawing/2014/main" id="{EAFA16CB-0A72-5AC5-69A0-ABF4A752B43F}"/>
-              </a:ext>
-            </a:extLst>
-          </p:cNvPr>
-          <p:cNvSpPr/>
-          <p:nvPr/>
-        </p:nvSpPr>
-        <p:spPr>
-          <a:xfrm>
-            <a:off x="1218724" y="1127372"/>
-            <a:ext cx="9214580" cy="4277001"/>
-          </a:xfrm>
-          <a:prstGeom prst="rect">
-            <a:avLst/>
-          </a:prstGeom>
-          <a:noFill/>
-          <a:ln>
-            <a:noFill/>
-          </a:ln>
-        </p:spPr>
-        <p:txBody>
-          <a:bodyPr spcFirstLastPara="1" wrap="square" lIns="0" tIns="0" rIns="0" bIns="0" anchor="t" anchorCtr="0">
-            <a:noAutofit/>
-          </a:bodyPr>
-          <a:lstStyle/>
-          <a:p>
-            <a:pPr>
-              <a:lnSpc>
-                <a:spcPct val="150000"/>
-              </a:lnSpc>
-              <a:buFont typeface="Arial"/>
-              <a:buChar char="•"/>
-            </a:pPr>
-            <a:r>
-              <a:rPr lang="en-US" sz="2000">
-                <a:solidFill>
-                  <a:srgbClr val="2B3541"/>
-                </a:solidFill>
-              </a:rPr>
-              <a:t>Assist healthcare professionals by providing </a:t>
-            </a:r>
-            <a:r>
-              <a:rPr lang="en-US" sz="2000" b="1">
-                <a:solidFill>
-                  <a:srgbClr val="2B3541"/>
-                </a:solidFill>
-              </a:rPr>
-              <a:t>quick and reliable preliminary breast cancer predictions</a:t>
-            </a:r>
-            <a:r>
-              <a:rPr lang="en-US" sz="2000">
-                <a:solidFill>
-                  <a:srgbClr val="2B3541"/>
-                </a:solidFill>
-              </a:rPr>
-              <a:t>, reducing diagnostic time. </a:t>
-            </a:r>
-            <a:endParaRPr lang="en-US" sz="2000"/>
-          </a:p>
-          <a:p>
-            <a:pPr>
-              <a:lnSpc>
-                <a:spcPct val="150000"/>
-              </a:lnSpc>
-              <a:buFont typeface="Arial"/>
-              <a:buChar char="•"/>
-            </a:pPr>
-            <a:r>
-              <a:rPr lang="en-US" sz="2000">
-                <a:solidFill>
-                  <a:srgbClr val="2B3541"/>
-                </a:solidFill>
-              </a:rPr>
-              <a:t>Promote </a:t>
-            </a:r>
-            <a:r>
-              <a:rPr lang="en-US" sz="2000" b="1">
-                <a:solidFill>
-                  <a:srgbClr val="2B3541"/>
-                </a:solidFill>
-              </a:rPr>
-              <a:t>early detection and timely medical intervention</a:t>
-            </a:r>
-            <a:r>
-              <a:rPr lang="en-US" sz="2000">
-                <a:solidFill>
-                  <a:srgbClr val="2B3541"/>
-                </a:solidFill>
-              </a:rPr>
-              <a:t>, improving treatment success rates and patient survival. </a:t>
-            </a:r>
-            <a:endParaRPr lang="en-US" sz="2000"/>
-          </a:p>
-          <a:p>
-            <a:pPr>
-              <a:lnSpc>
-                <a:spcPct val="150000"/>
-              </a:lnSpc>
-              <a:buFont typeface="Arial"/>
-              <a:buChar char="•"/>
-            </a:pPr>
-            <a:r>
-              <a:rPr lang="en-US" sz="2000">
-                <a:solidFill>
-                  <a:srgbClr val="2B3541"/>
-                </a:solidFill>
-              </a:rPr>
-              <a:t>Increase </a:t>
-            </a:r>
-            <a:r>
-              <a:rPr lang="en-US" sz="2000" b="1">
-                <a:solidFill>
-                  <a:srgbClr val="2B3541"/>
-                </a:solidFill>
-              </a:rPr>
-              <a:t>breast cancer awareness</a:t>
-            </a:r>
-            <a:r>
-              <a:rPr lang="en-US" sz="2000">
-                <a:solidFill>
-                  <a:srgbClr val="2B3541"/>
-                </a:solidFill>
-              </a:rPr>
-              <a:t> by educating users about risk factors, symptoms, and preventive measures. </a:t>
-            </a:r>
-            <a:endParaRPr lang="en-US" sz="2000"/>
-          </a:p>
-          <a:p>
-            <a:pPr>
-              <a:lnSpc>
-                <a:spcPct val="150000"/>
-              </a:lnSpc>
-              <a:buFont typeface="Arial"/>
-              <a:buChar char="•"/>
-            </a:pPr>
-            <a:r>
-              <a:rPr lang="en-US" sz="2000">
-                <a:solidFill>
-                  <a:srgbClr val="2B3541"/>
-                </a:solidFill>
-              </a:rPr>
-              <a:t>Be integrated into </a:t>
-            </a:r>
-            <a:r>
-              <a:rPr lang="en-US" sz="2000" b="1">
-                <a:solidFill>
-                  <a:srgbClr val="2B3541"/>
-                </a:solidFill>
-              </a:rPr>
-              <a:t>hospitals, diagnostic centers, and healthcare systems</a:t>
-            </a:r>
-            <a:r>
-              <a:rPr lang="en-US" sz="2000">
-                <a:solidFill>
-                  <a:srgbClr val="2B3541"/>
-                </a:solidFill>
-              </a:rPr>
-              <a:t> as an AI-assisted decision support tool. </a:t>
-            </a:r>
-            <a:endParaRPr lang="en-US" sz="2000"/>
-          </a:p>
-          <a:p>
-            <a:pPr>
-              <a:lnSpc>
-                <a:spcPct val="150000"/>
-              </a:lnSpc>
-              <a:buFont typeface="Arial"/>
-              <a:buChar char="•"/>
-            </a:pPr>
-            <a:r>
-              <a:rPr lang="en-US" sz="2000">
-                <a:solidFill>
-                  <a:srgbClr val="2B3541"/>
-                </a:solidFill>
-              </a:rPr>
-              <a:t>Improve healthcare accessibility by enabling </a:t>
-            </a:r>
-            <a:r>
-              <a:rPr lang="en-US" sz="2000" b="1">
-                <a:solidFill>
-                  <a:srgbClr val="2B3541"/>
-                </a:solidFill>
-              </a:rPr>
-              <a:t>remote breast cancer risk assessment</a:t>
-            </a:r>
-            <a:r>
-              <a:rPr lang="en-US" sz="2000">
-                <a:solidFill>
-                  <a:srgbClr val="2B3541"/>
-                </a:solidFill>
-              </a:rPr>
-              <a:t>, especially for people in rural and underserved areas. </a:t>
-            </a:r>
-            <a:endParaRPr lang="en-US" sz="2000"/>
-          </a:p>
-          <a:p>
-            <a:pPr>
-              <a:lnSpc>
-                <a:spcPct val="150000"/>
-              </a:lnSpc>
-              <a:buFont typeface="Arial"/>
-              <a:buChar char="•"/>
-            </a:pPr>
-            <a:r>
-              <a:rPr lang="en-US" sz="2000">
-                <a:solidFill>
-                  <a:srgbClr val="2B3541"/>
-                </a:solidFill>
-              </a:rPr>
-              <a:t>Support doctors by acting as a </a:t>
-            </a:r>
-            <a:r>
-              <a:rPr lang="en-US" sz="2000" b="1">
-                <a:solidFill>
-                  <a:srgbClr val="2B3541"/>
-                </a:solidFill>
-              </a:rPr>
-              <a:t>clinical decision-support system</a:t>
-            </a:r>
-            <a:r>
-              <a:rPr lang="en-US" sz="2000">
-                <a:solidFill>
-                  <a:srgbClr val="2B3541"/>
-                </a:solidFill>
-              </a:rPr>
-              <a:t>, reducing  </a:t>
-            </a:r>
-            <a:endParaRPr lang="en-US" sz="2000"/>
-          </a:p>
-          <a:p>
-            <a:pPr marL="285750" indent="-285750">
-              <a:lnSpc>
-                <a:spcPct val="150000"/>
-              </a:lnSpc>
-              <a:buFont typeface="Arial"/>
-              <a:buChar char="•"/>
-            </a:pPr>
-            <a:endParaRPr lang="en-US" sz="1850" dirty="0">
-              <a:solidFill>
-                <a:srgbClr val="2B3541"/>
-              </a:solidFill>
-            </a:endParaRPr>
-          </a:p>
-          <a:p>
-            <a:pPr marL="0" marR="0" lvl="0" indent="0" algn="l">
-              <a:lnSpc>
-                <a:spcPct val="150000"/>
-              </a:lnSpc>
-              <a:spcBef>
-                <a:spcPts val="0"/>
-              </a:spcBef>
-              <a:spcAft>
-                <a:spcPts val="0"/>
-              </a:spcAft>
-              <a:buSzPts val="1850"/>
-              <a:buFont typeface="Times New Roman"/>
-              <a:buNone/>
-            </a:pPr>
-            <a:endParaRPr lang="en-US" sz="1850" b="1">
-              <a:solidFill>
-                <a:srgbClr val="2B3541"/>
-              </a:solidFill>
-              <a:latin typeface="Times New Roman"/>
-              <a:cs typeface="Times New Roman"/>
-            </a:endParaRPr>
-          </a:p>
-        </p:txBody>
-      </p:sp>
-      <p:sp>
-        <p:nvSpPr>
-          <p:cNvPr id="280" name="Google Shape;280;p18">
-            <a:extLst>
-              <a:ext uri="{FF2B5EF4-FFF2-40B4-BE49-F238E27FC236}">
-                <a16:creationId xmlns:a16="http://schemas.microsoft.com/office/drawing/2014/main" id="{B888011B-E4AC-77DB-4A60-BE2C891C49F5}"/>
-              </a:ext>
-            </a:extLst>
-          </p:cNvPr>
-          <p:cNvSpPr/>
-          <p:nvPr/>
-        </p:nvSpPr>
-        <p:spPr>
-          <a:xfrm>
-            <a:off x="1218724" y="3360216"/>
-            <a:ext cx="7468553" cy="766048"/>
-          </a:xfrm>
-          <a:prstGeom prst="rect">
-            <a:avLst/>
-          </a:prstGeom>
-          <a:noFill/>
-          <a:ln>
-            <a:noFill/>
-          </a:ln>
-        </p:spPr>
-        <p:txBody>
-          <a:bodyPr spcFirstLastPara="1" wrap="square" lIns="0" tIns="0" rIns="0" bIns="0" anchor="t" anchorCtr="0">
-            <a:noAutofit/>
-          </a:bodyPr>
-          <a:lstStyle/>
-          <a:p>
-            <a:pPr marL="0" marR="0" lvl="0" indent="0" algn="l" rtl="0">
-              <a:lnSpc>
-                <a:spcPct val="162162"/>
-              </a:lnSpc>
-              <a:spcBef>
-                <a:spcPts val="0"/>
-              </a:spcBef>
-              <a:spcAft>
-                <a:spcPts val="0"/>
-              </a:spcAft>
-              <a:buClr>
-                <a:srgbClr val="2B3541"/>
-              </a:buClr>
-              <a:buSzPts val="1850"/>
-              <a:buFont typeface="Times New Roman"/>
-              <a:buNone/>
-            </a:pPr>
-            <a:r>
-              <a:rPr lang="en-US" sz="1850" b="0" i="0" u="none" strike="noStrike" cap="none">
-                <a:solidFill>
-                  <a:srgbClr val="2B3541"/>
-                </a:solidFill>
-                <a:latin typeface="Times New Roman"/>
-                <a:ea typeface="Times New Roman"/>
-                <a:cs typeface="Times New Roman"/>
-                <a:sym typeface="Times New Roman"/>
-              </a:rPr>
-              <a:t>·</a:t>
-            </a:r>
-            <a:endParaRPr sz="1850" b="0" i="0" u="none" strike="noStrike" cap="none">
-              <a:solidFill>
-                <a:srgbClr val="000000"/>
-              </a:solidFill>
-              <a:latin typeface="Times New Roman"/>
-              <a:ea typeface="Times New Roman"/>
-              <a:cs typeface="Times New Roman"/>
-              <a:sym typeface="Times New Roman"/>
-            </a:endParaRPr>
-          </a:p>
-        </p:txBody>
-      </p:sp>
-      <p:sp>
-        <p:nvSpPr>
-          <p:cNvPr id="281" name="Google Shape;281;p18">
-            <a:extLst>
-              <a:ext uri="{FF2B5EF4-FFF2-40B4-BE49-F238E27FC236}">
-                <a16:creationId xmlns:a16="http://schemas.microsoft.com/office/drawing/2014/main" id="{91F05971-9256-10B5-6575-4E7C679C6DAA}"/>
-              </a:ext>
-            </a:extLst>
-          </p:cNvPr>
-          <p:cNvSpPr/>
-          <p:nvPr/>
-        </p:nvSpPr>
-        <p:spPr>
-          <a:xfrm>
-            <a:off x="1218724" y="4395464"/>
-            <a:ext cx="7468553" cy="766048"/>
-          </a:xfrm>
-          <a:prstGeom prst="rect">
-            <a:avLst/>
-          </a:prstGeom>
-          <a:noFill/>
-          <a:ln>
-            <a:noFill/>
-          </a:ln>
-        </p:spPr>
-        <p:txBody>
-          <a:bodyPr spcFirstLastPara="1" wrap="square" lIns="0" tIns="0" rIns="0" bIns="0" anchor="t" anchorCtr="0">
-            <a:noAutofit/>
-          </a:bodyPr>
-          <a:lstStyle/>
-          <a:p>
-            <a:pPr marL="0" marR="0" lvl="0" indent="0" algn="l" rtl="0">
-              <a:lnSpc>
-                <a:spcPct val="162162"/>
-              </a:lnSpc>
-              <a:spcBef>
-                <a:spcPts val="0"/>
-              </a:spcBef>
-              <a:spcAft>
-                <a:spcPts val="0"/>
-              </a:spcAft>
-              <a:buClr>
-                <a:srgbClr val="2B3541"/>
-              </a:buClr>
-              <a:buSzPts val="1850"/>
-              <a:buFont typeface="Times New Roman"/>
-              <a:buNone/>
-            </a:pPr>
-            <a:r>
-              <a:rPr lang="en-US" sz="1850" b="0" i="0" u="none" strike="noStrike" cap="none">
-                <a:solidFill>
-                  <a:srgbClr val="2B3541"/>
-                </a:solidFill>
-                <a:latin typeface="Times New Roman"/>
-                <a:ea typeface="Times New Roman"/>
-                <a:cs typeface="Times New Roman"/>
-                <a:sym typeface="Times New Roman"/>
-              </a:rPr>
-              <a:t>·</a:t>
-            </a:r>
-            <a:endParaRPr sz="1850" b="0" i="0" u="none" strike="noStrike" cap="none">
-              <a:solidFill>
-                <a:srgbClr val="000000"/>
-              </a:solidFill>
-              <a:latin typeface="Times New Roman"/>
-              <a:ea typeface="Times New Roman"/>
-              <a:cs typeface="Times New Roman"/>
-              <a:sym typeface="Times New Roman"/>
-            </a:endParaRPr>
-          </a:p>
-        </p:txBody>
-      </p:sp>
-      <p:sp>
-        <p:nvSpPr>
-          <p:cNvPr id="282" name="Google Shape;282;p18">
-            <a:extLst>
-              <a:ext uri="{FF2B5EF4-FFF2-40B4-BE49-F238E27FC236}">
-                <a16:creationId xmlns:a16="http://schemas.microsoft.com/office/drawing/2014/main" id="{F1C3EBC2-438F-C150-9ABF-F14321C2CC5C}"/>
-              </a:ext>
-            </a:extLst>
-          </p:cNvPr>
-          <p:cNvSpPr/>
-          <p:nvPr/>
-        </p:nvSpPr>
-        <p:spPr>
-          <a:xfrm>
-            <a:off x="1218724" y="5430713"/>
-            <a:ext cx="7468553" cy="383024"/>
-          </a:xfrm>
-          <a:prstGeom prst="rect">
-            <a:avLst/>
-          </a:prstGeom>
-          <a:noFill/>
-          <a:ln>
-            <a:noFill/>
-          </a:ln>
-        </p:spPr>
-        <p:txBody>
-          <a:bodyPr spcFirstLastPara="1" wrap="square" lIns="0" tIns="0" rIns="0" bIns="0" anchor="t" anchorCtr="0">
-            <a:noAutofit/>
-          </a:bodyPr>
-          <a:lstStyle/>
-          <a:p>
-            <a:pPr marL="0" marR="0" lvl="0" indent="0" algn="l" rtl="0">
-              <a:lnSpc>
-                <a:spcPct val="162162"/>
-              </a:lnSpc>
-              <a:spcBef>
-                <a:spcPts val="0"/>
-              </a:spcBef>
-              <a:spcAft>
-                <a:spcPts val="0"/>
-              </a:spcAft>
-              <a:buClr>
-                <a:srgbClr val="2B3541"/>
-              </a:buClr>
-              <a:buSzPts val="1850"/>
-              <a:buFont typeface="Times New Roman"/>
-              <a:buNone/>
-            </a:pPr>
-            <a:r>
-              <a:rPr lang="en-US" sz="1850" b="0" i="0" u="none" strike="noStrike" cap="none">
-                <a:solidFill>
-                  <a:srgbClr val="2B3541"/>
-                </a:solidFill>
-                <a:latin typeface="Times New Roman"/>
-                <a:ea typeface="Times New Roman"/>
-                <a:cs typeface="Times New Roman"/>
-                <a:sym typeface="Times New Roman"/>
-              </a:rPr>
-              <a:t>·</a:t>
-            </a:r>
-            <a:endParaRPr sz="1850" b="0" i="0" u="none" strike="noStrike" cap="none">
-              <a:solidFill>
-                <a:srgbClr val="000000"/>
-              </a:solidFill>
-              <a:latin typeface="Times New Roman"/>
-              <a:ea typeface="Times New Roman"/>
-              <a:cs typeface="Times New Roman"/>
-              <a:sym typeface="Times New Roman"/>
-            </a:endParaRPr>
-          </a:p>
-        </p:txBody>
-      </p:sp>
-    </p:spTree>
-    <p:extLst>
-      <p:ext uri="{BB962C8B-B14F-4D97-AF65-F5344CB8AC3E}">
-        <p14:creationId xmlns:p14="http://schemas.microsoft.com/office/powerpoint/2010/main" val="2136706720"/>
-      </p:ext>
-    </p:extLst>
-  </p:cSld>
-  <p:clrMapOvr>
-    <a:masterClrMapping/>
-  </p:clrMapOvr>
-</p:sld>
-</file>
-
-<file path=ppt/slides/slide29.xml><?xml version="1.0" encoding="utf-8"?>
-<p:sld xmlns:a="http://schemas.openxmlformats.org/drawingml/2006/main" xmlns:r="http://schemas.openxmlformats.org/officeDocument/2006/relationships" xmlns:p="http://schemas.openxmlformats.org/presentationml/2006/main">
-  <p:cSld>
-    <p:spTree>
-      <p:nvGrpSpPr>
-        <p:cNvPr id="1" name=""/>
-        <p:cNvGrpSpPr/>
-        <p:nvPr/>
-      </p:nvGrpSpPr>
-      <p:grpSpPr>
-        <a:xfrm>
-          <a:off x="0" y="0"/>
-          <a:ext cx="0" cy="0"/>
-          <a:chOff x="0" y="0"/>
-          <a:chExt cx="0" cy="0"/>
-        </a:xfrm>
-      </p:grpSpPr>
-      <p:sp>
-        <p:nvSpPr>
-          <p:cNvPr id="4" name="TextBox 3">
-            <a:extLst>
-              <a:ext uri="{FF2B5EF4-FFF2-40B4-BE49-F238E27FC236}">
-                <a16:creationId xmlns:a16="http://schemas.microsoft.com/office/drawing/2014/main" id="{990A5436-28E0-E58C-12FD-233FBF3F3968}"/>
-              </a:ext>
-            </a:extLst>
-          </p:cNvPr>
-          <p:cNvSpPr txBox="1"/>
-          <p:nvPr/>
-        </p:nvSpPr>
-        <p:spPr>
-          <a:xfrm>
-            <a:off x="212595" y="589966"/>
-            <a:ext cx="11533249" cy="2616101"/>
-          </a:xfrm>
-          <a:prstGeom prst="rect">
-            <a:avLst/>
-          </a:prstGeom>
-          <a:noFill/>
-        </p:spPr>
-        <p:txBody>
-          <a:bodyPr rot="0" spcFirstLastPara="0" vertOverflow="overflow" horzOverflow="overflow" vert="horz" wrap="square" lIns="91440" tIns="45720" rIns="91440" bIns="45720" numCol="1" spcCol="0" rtlCol="0" fromWordArt="0" anchor="t" anchorCtr="0" forceAA="0" compatLnSpc="1">
-            <a:prstTxWarp prst="textNoShape">
-              <a:avLst/>
-            </a:prstTxWarp>
-            <a:spAutoFit/>
-          </a:bodyPr>
-          <a:lstStyle/>
-          <a:p>
-            <a:pPr>
-              <a:lnSpc>
-                <a:spcPct val="150000"/>
-              </a:lnSpc>
-            </a:pPr>
-            <a:r>
-              <a:rPr lang="en-US" sz="2000">
-                <a:solidFill>
-                  <a:srgbClr val="2B3541"/>
-                </a:solidFill>
-              </a:rPr>
-              <a:t>    manual effort and assisting in data-driven diagnosis.</a:t>
-            </a:r>
-            <a:endParaRPr lang="en-US" sz="2000" dirty="0">
-              <a:solidFill>
-                <a:srgbClr val="2B3541"/>
-              </a:solidFill>
-            </a:endParaRPr>
-          </a:p>
-          <a:p>
-            <a:pPr marL="285750" indent="-285750">
-              <a:lnSpc>
-                <a:spcPct val="150000"/>
-              </a:lnSpc>
-              <a:buFont typeface="Arial,Sans-Serif"/>
-              <a:buChar char="•"/>
-            </a:pPr>
-            <a:r>
-              <a:rPr lang="en-US" sz="2000">
-                <a:solidFill>
-                  <a:srgbClr val="2B3541"/>
-                </a:solidFill>
-              </a:rPr>
-              <a:t>Expand into a comprehensive healthcare platform capable of predicting </a:t>
-            </a:r>
-            <a:r>
-              <a:rPr lang="en-US" sz="2000" b="1">
-                <a:solidFill>
-                  <a:srgbClr val="2B3541"/>
-                </a:solidFill>
-              </a:rPr>
-              <a:t>multiple diseases</a:t>
-            </a:r>
-            <a:r>
-              <a:rPr lang="en-US" sz="2000">
-                <a:solidFill>
-                  <a:srgbClr val="2B3541"/>
-                </a:solidFill>
-              </a:rPr>
-              <a:t> using advanced AI and machine learning models. </a:t>
-            </a:r>
-            <a:endParaRPr lang="en-US" sz="2000"/>
-          </a:p>
-          <a:p>
-            <a:pPr marL="285750" indent="-285750">
-              <a:lnSpc>
-                <a:spcPct val="150000"/>
-              </a:lnSpc>
-              <a:buFont typeface="Arial,Sans-Serif"/>
-              <a:buChar char="•"/>
-            </a:pPr>
-            <a:r>
-              <a:rPr lang="en-US" sz="2000">
-                <a:solidFill>
-                  <a:srgbClr val="2B3541"/>
-                </a:solidFill>
-              </a:rPr>
-              <a:t>Contribute to the advancement of </a:t>
-            </a:r>
-            <a:r>
-              <a:rPr lang="en-US" sz="2000" b="1">
-                <a:solidFill>
-                  <a:srgbClr val="2B3541"/>
-                </a:solidFill>
-              </a:rPr>
-              <a:t>AI-powered healthcare</a:t>
-            </a:r>
-            <a:r>
-              <a:rPr lang="en-US" sz="2000">
-                <a:solidFill>
-                  <a:srgbClr val="2B3541"/>
-                </a:solidFill>
-              </a:rPr>
-              <a:t>, making medical screening faster, more accurate, and accessible to a larger population.</a:t>
-            </a:r>
-            <a:endParaRPr lang="en-US" sz="2000"/>
-          </a:p>
-          <a:p>
-            <a:pPr algn="l"/>
-            <a:endParaRPr lang="en-US" dirty="0"/>
-          </a:p>
-        </p:txBody>
-      </p:sp>
-    </p:spTree>
-    <p:extLst>
-      <p:ext uri="{BB962C8B-B14F-4D97-AF65-F5344CB8AC3E}">
-        <p14:creationId xmlns:p14="http://schemas.microsoft.com/office/powerpoint/2010/main" val="215885403"/>
       </p:ext>
     </p:extLst>
   </p:cSld>
@@ -15780,6 +15112,1110 @@
   <p:cSld>
     <p:spTree>
       <p:nvGrpSpPr>
+        <p:cNvPr id="1" name="Shape 274">
+          <a:extLst>
+            <a:ext uri="{FF2B5EF4-FFF2-40B4-BE49-F238E27FC236}">
+              <a16:creationId xmlns:a16="http://schemas.microsoft.com/office/drawing/2014/main" id="{7BB3C0CA-2F24-30DF-1D65-4440B864F08E}"/>
+            </a:ext>
+          </a:extLst>
+        </p:cNvPr>
+        <p:cNvGrpSpPr/>
+        <p:nvPr/>
+      </p:nvGrpSpPr>
+      <p:grpSpPr>
+        <a:xfrm>
+          <a:off x="0" y="0"/>
+          <a:ext cx="0" cy="0"/>
+          <a:chOff x="0" y="0"/>
+          <a:chExt cx="0" cy="0"/>
+        </a:xfrm>
+      </p:grpSpPr>
+      <p:sp>
+        <p:nvSpPr>
+          <p:cNvPr id="278" name="Google Shape;278;p18">
+            <a:extLst>
+              <a:ext uri="{FF2B5EF4-FFF2-40B4-BE49-F238E27FC236}">
+                <a16:creationId xmlns:a16="http://schemas.microsoft.com/office/drawing/2014/main" id="{187EEB9C-2E84-113A-3CE6-1507BF5B039F}"/>
+              </a:ext>
+            </a:extLst>
+          </p:cNvPr>
+          <p:cNvSpPr/>
+          <p:nvPr/>
+        </p:nvSpPr>
+        <p:spPr>
+          <a:xfrm>
+            <a:off x="1218724" y="420729"/>
+            <a:ext cx="6444496" cy="704017"/>
+          </a:xfrm>
+          <a:prstGeom prst="rect">
+            <a:avLst/>
+          </a:prstGeom>
+          <a:noFill/>
+          <a:ln>
+            <a:noFill/>
+          </a:ln>
+        </p:spPr>
+        <p:txBody>
+          <a:bodyPr spcFirstLastPara="1" wrap="square" lIns="0" tIns="0" rIns="0" bIns="0" anchor="t" anchorCtr="0">
+            <a:noAutofit/>
+          </a:bodyPr>
+          <a:lstStyle/>
+          <a:p>
+            <a:pPr marL="0" marR="0" lvl="0" indent="0" algn="l" rtl="0">
+              <a:lnSpc>
+                <a:spcPct val="157142"/>
+              </a:lnSpc>
+              <a:spcBef>
+                <a:spcPts val="0"/>
+              </a:spcBef>
+              <a:spcAft>
+                <a:spcPts val="0"/>
+              </a:spcAft>
+              <a:buClr>
+                <a:srgbClr val="051D3A"/>
+              </a:buClr>
+              <a:buSzPts val="3500"/>
+              <a:buFont typeface="Times New Roman"/>
+              <a:buNone/>
+            </a:pPr>
+            <a:r>
+              <a:rPr lang="en-US" sz="2400" b="1">
+                <a:sym typeface="Times New Roman"/>
+              </a:rPr>
+              <a:t>Git Hub Link</a:t>
+            </a:r>
+            <a:endParaRPr sz="2400" b="1">
+              <a:sym typeface="Times New Roman"/>
+            </a:endParaRPr>
+          </a:p>
+        </p:txBody>
+      </p:sp>
+      <p:sp>
+        <p:nvSpPr>
+          <p:cNvPr id="279" name="Google Shape;279;p18">
+            <a:extLst>
+              <a:ext uri="{FF2B5EF4-FFF2-40B4-BE49-F238E27FC236}">
+                <a16:creationId xmlns:a16="http://schemas.microsoft.com/office/drawing/2014/main" id="{3711AF54-94A6-B837-31EF-9A8C4ECB9AF6}"/>
+              </a:ext>
+            </a:extLst>
+          </p:cNvPr>
+          <p:cNvSpPr/>
+          <p:nvPr/>
+        </p:nvSpPr>
+        <p:spPr>
+          <a:xfrm>
+            <a:off x="1218724" y="1153712"/>
+            <a:ext cx="9214580" cy="4277001"/>
+          </a:xfrm>
+          <a:prstGeom prst="rect">
+            <a:avLst/>
+          </a:prstGeom>
+          <a:noFill/>
+          <a:ln>
+            <a:noFill/>
+          </a:ln>
+        </p:spPr>
+        <p:txBody>
+          <a:bodyPr spcFirstLastPara="1" wrap="square" lIns="0" tIns="0" rIns="0" bIns="0" anchor="t" anchorCtr="0">
+            <a:noAutofit/>
+          </a:bodyPr>
+          <a:lstStyle/>
+          <a:p>
+            <a:pPr marL="0" marR="0" lvl="0" indent="0" algn="l">
+              <a:lnSpc>
+                <a:spcPct val="162162"/>
+              </a:lnSpc>
+              <a:spcBef>
+                <a:spcPts val="0"/>
+              </a:spcBef>
+              <a:spcAft>
+                <a:spcPts val="0"/>
+              </a:spcAft>
+              <a:buNone/>
+            </a:pPr>
+            <a:r>
+              <a:rPr lang="en-US" sz="1850" dirty="0">
+                <a:hlinkClick r:id="rId3"/>
+              </a:rPr>
+              <a:t>https://github.com/lakshmisatwika28-lang/Breast-Cancer-Prediction-AutoAI.git</a:t>
+            </a:r>
+            <a:endParaRPr lang="en-US"/>
+          </a:p>
+        </p:txBody>
+      </p:sp>
+      <p:sp>
+        <p:nvSpPr>
+          <p:cNvPr id="280" name="Google Shape;280;p18">
+            <a:extLst>
+              <a:ext uri="{FF2B5EF4-FFF2-40B4-BE49-F238E27FC236}">
+                <a16:creationId xmlns:a16="http://schemas.microsoft.com/office/drawing/2014/main" id="{E228982D-BF81-530A-CBA1-E897A3CA8EF7}"/>
+              </a:ext>
+            </a:extLst>
+          </p:cNvPr>
+          <p:cNvSpPr/>
+          <p:nvPr/>
+        </p:nvSpPr>
+        <p:spPr>
+          <a:xfrm>
+            <a:off x="1218724" y="3360216"/>
+            <a:ext cx="7468553" cy="766048"/>
+          </a:xfrm>
+          <a:prstGeom prst="rect">
+            <a:avLst/>
+          </a:prstGeom>
+          <a:noFill/>
+          <a:ln>
+            <a:noFill/>
+          </a:ln>
+        </p:spPr>
+        <p:txBody>
+          <a:bodyPr spcFirstLastPara="1" wrap="square" lIns="0" tIns="0" rIns="0" bIns="0" anchor="t" anchorCtr="0">
+            <a:noAutofit/>
+          </a:bodyPr>
+          <a:lstStyle/>
+          <a:p>
+            <a:pPr marL="0" marR="0" lvl="0" indent="0" algn="l" rtl="0">
+              <a:lnSpc>
+                <a:spcPct val="162162"/>
+              </a:lnSpc>
+              <a:spcBef>
+                <a:spcPts val="0"/>
+              </a:spcBef>
+              <a:spcAft>
+                <a:spcPts val="0"/>
+              </a:spcAft>
+              <a:buClr>
+                <a:srgbClr val="2B3541"/>
+              </a:buClr>
+              <a:buSzPts val="1850"/>
+              <a:buFont typeface="Times New Roman"/>
+              <a:buNone/>
+            </a:pPr>
+            <a:r>
+              <a:rPr lang="en-US" sz="1850" b="0" i="0" u="none" strike="noStrike" cap="none">
+                <a:solidFill>
+                  <a:srgbClr val="2B3541"/>
+                </a:solidFill>
+                <a:latin typeface="Times New Roman"/>
+                <a:ea typeface="Times New Roman"/>
+                <a:cs typeface="Times New Roman"/>
+                <a:sym typeface="Times New Roman"/>
+              </a:rPr>
+              <a:t>·</a:t>
+            </a:r>
+            <a:endParaRPr sz="1850" b="0" i="0" u="none" strike="noStrike" cap="none">
+              <a:solidFill>
+                <a:srgbClr val="000000"/>
+              </a:solidFill>
+              <a:latin typeface="Times New Roman"/>
+              <a:ea typeface="Times New Roman"/>
+              <a:cs typeface="Times New Roman"/>
+              <a:sym typeface="Times New Roman"/>
+            </a:endParaRPr>
+          </a:p>
+        </p:txBody>
+      </p:sp>
+      <p:sp>
+        <p:nvSpPr>
+          <p:cNvPr id="281" name="Google Shape;281;p18">
+            <a:extLst>
+              <a:ext uri="{FF2B5EF4-FFF2-40B4-BE49-F238E27FC236}">
+                <a16:creationId xmlns:a16="http://schemas.microsoft.com/office/drawing/2014/main" id="{7BC356B8-92F8-3187-D065-667AACF68E72}"/>
+              </a:ext>
+            </a:extLst>
+          </p:cNvPr>
+          <p:cNvSpPr/>
+          <p:nvPr/>
+        </p:nvSpPr>
+        <p:spPr>
+          <a:xfrm>
+            <a:off x="1218724" y="4395464"/>
+            <a:ext cx="7468553" cy="766048"/>
+          </a:xfrm>
+          <a:prstGeom prst="rect">
+            <a:avLst/>
+          </a:prstGeom>
+          <a:noFill/>
+          <a:ln>
+            <a:noFill/>
+          </a:ln>
+        </p:spPr>
+        <p:txBody>
+          <a:bodyPr spcFirstLastPara="1" wrap="square" lIns="0" tIns="0" rIns="0" bIns="0" anchor="t" anchorCtr="0">
+            <a:noAutofit/>
+          </a:bodyPr>
+          <a:lstStyle/>
+          <a:p>
+            <a:pPr marL="0" marR="0" lvl="0" indent="0" algn="l" rtl="0">
+              <a:lnSpc>
+                <a:spcPct val="162162"/>
+              </a:lnSpc>
+              <a:spcBef>
+                <a:spcPts val="0"/>
+              </a:spcBef>
+              <a:spcAft>
+                <a:spcPts val="0"/>
+              </a:spcAft>
+              <a:buClr>
+                <a:srgbClr val="2B3541"/>
+              </a:buClr>
+              <a:buSzPts val="1850"/>
+              <a:buFont typeface="Times New Roman"/>
+              <a:buNone/>
+            </a:pPr>
+            <a:r>
+              <a:rPr lang="en-US" sz="1850" b="0" i="0" u="none" strike="noStrike" cap="none">
+                <a:solidFill>
+                  <a:srgbClr val="2B3541"/>
+                </a:solidFill>
+                <a:latin typeface="Times New Roman"/>
+                <a:ea typeface="Times New Roman"/>
+                <a:cs typeface="Times New Roman"/>
+                <a:sym typeface="Times New Roman"/>
+              </a:rPr>
+              <a:t>·</a:t>
+            </a:r>
+            <a:endParaRPr sz="1850" b="0" i="0" u="none" strike="noStrike" cap="none">
+              <a:solidFill>
+                <a:srgbClr val="000000"/>
+              </a:solidFill>
+              <a:latin typeface="Times New Roman"/>
+              <a:ea typeface="Times New Roman"/>
+              <a:cs typeface="Times New Roman"/>
+              <a:sym typeface="Times New Roman"/>
+            </a:endParaRPr>
+          </a:p>
+        </p:txBody>
+      </p:sp>
+      <p:sp>
+        <p:nvSpPr>
+          <p:cNvPr id="282" name="Google Shape;282;p18">
+            <a:extLst>
+              <a:ext uri="{FF2B5EF4-FFF2-40B4-BE49-F238E27FC236}">
+                <a16:creationId xmlns:a16="http://schemas.microsoft.com/office/drawing/2014/main" id="{1558A011-60D6-B010-6117-1B9F7C786B2B}"/>
+              </a:ext>
+            </a:extLst>
+          </p:cNvPr>
+          <p:cNvSpPr/>
+          <p:nvPr/>
+        </p:nvSpPr>
+        <p:spPr>
+          <a:xfrm>
+            <a:off x="1218724" y="5430713"/>
+            <a:ext cx="7468553" cy="383024"/>
+          </a:xfrm>
+          <a:prstGeom prst="rect">
+            <a:avLst/>
+          </a:prstGeom>
+          <a:noFill/>
+          <a:ln>
+            <a:noFill/>
+          </a:ln>
+        </p:spPr>
+        <p:txBody>
+          <a:bodyPr spcFirstLastPara="1" wrap="square" lIns="0" tIns="0" rIns="0" bIns="0" anchor="t" anchorCtr="0">
+            <a:noAutofit/>
+          </a:bodyPr>
+          <a:lstStyle/>
+          <a:p>
+            <a:pPr marL="0" marR="0" lvl="0" indent="0" algn="l" rtl="0">
+              <a:lnSpc>
+                <a:spcPct val="162162"/>
+              </a:lnSpc>
+              <a:spcBef>
+                <a:spcPts val="0"/>
+              </a:spcBef>
+              <a:spcAft>
+                <a:spcPts val="0"/>
+              </a:spcAft>
+              <a:buClr>
+                <a:srgbClr val="2B3541"/>
+              </a:buClr>
+              <a:buSzPts val="1850"/>
+              <a:buFont typeface="Times New Roman"/>
+              <a:buNone/>
+            </a:pPr>
+            <a:r>
+              <a:rPr lang="en-US" sz="1850" b="0" i="0" u="none" strike="noStrike" cap="none">
+                <a:solidFill>
+                  <a:srgbClr val="2B3541"/>
+                </a:solidFill>
+                <a:latin typeface="Times New Roman"/>
+                <a:ea typeface="Times New Roman"/>
+                <a:cs typeface="Times New Roman"/>
+                <a:sym typeface="Times New Roman"/>
+              </a:rPr>
+              <a:t>·</a:t>
+            </a:r>
+            <a:endParaRPr sz="1850" b="0" i="0" u="none" strike="noStrike" cap="none">
+              <a:solidFill>
+                <a:srgbClr val="000000"/>
+              </a:solidFill>
+              <a:latin typeface="Times New Roman"/>
+              <a:ea typeface="Times New Roman"/>
+              <a:cs typeface="Times New Roman"/>
+              <a:sym typeface="Times New Roman"/>
+            </a:endParaRPr>
+          </a:p>
+        </p:txBody>
+      </p:sp>
+    </p:spTree>
+    <p:extLst>
+      <p:ext uri="{BB962C8B-B14F-4D97-AF65-F5344CB8AC3E}">
+        <p14:creationId xmlns:p14="http://schemas.microsoft.com/office/powerpoint/2010/main" val="2605851928"/>
+      </p:ext>
+    </p:extLst>
+  </p:cSld>
+  <p:clrMapOvr>
+    <a:masterClrMapping/>
+  </p:clrMapOvr>
+</p:sld>
+</file>
+
+<file path=ppt/slides/slide31.xml><?xml version="1.0" encoding="utf-8"?>
+<p:sld xmlns:a="http://schemas.openxmlformats.org/drawingml/2006/main" xmlns:r="http://schemas.openxmlformats.org/officeDocument/2006/relationships" xmlns:p="http://schemas.openxmlformats.org/presentationml/2006/main">
+  <p:cSld>
+    <p:spTree>
+      <p:nvGrpSpPr>
+        <p:cNvPr id="1" name="Shape 274">
+          <a:extLst>
+            <a:ext uri="{FF2B5EF4-FFF2-40B4-BE49-F238E27FC236}">
+              <a16:creationId xmlns:a16="http://schemas.microsoft.com/office/drawing/2014/main" id="{6FA0F82B-7EE5-EAB0-F470-130BDAC8254B}"/>
+            </a:ext>
+          </a:extLst>
+        </p:cNvPr>
+        <p:cNvGrpSpPr/>
+        <p:nvPr/>
+      </p:nvGrpSpPr>
+      <p:grpSpPr>
+        <a:xfrm>
+          <a:off x="0" y="0"/>
+          <a:ext cx="0" cy="0"/>
+          <a:chOff x="0" y="0"/>
+          <a:chExt cx="0" cy="0"/>
+        </a:xfrm>
+      </p:grpSpPr>
+      <p:sp>
+        <p:nvSpPr>
+          <p:cNvPr id="278" name="Google Shape;278;p18">
+            <a:extLst>
+              <a:ext uri="{FF2B5EF4-FFF2-40B4-BE49-F238E27FC236}">
+                <a16:creationId xmlns:a16="http://schemas.microsoft.com/office/drawing/2014/main" id="{0668C6FD-577A-7288-5642-1AFC22BD04F2}"/>
+              </a:ext>
+            </a:extLst>
+          </p:cNvPr>
+          <p:cNvSpPr/>
+          <p:nvPr/>
+        </p:nvSpPr>
+        <p:spPr>
+          <a:xfrm>
+            <a:off x="1218724" y="420729"/>
+            <a:ext cx="6444496" cy="704017"/>
+          </a:xfrm>
+          <a:prstGeom prst="rect">
+            <a:avLst/>
+          </a:prstGeom>
+          <a:noFill/>
+          <a:ln>
+            <a:noFill/>
+          </a:ln>
+        </p:spPr>
+        <p:txBody>
+          <a:bodyPr spcFirstLastPara="1" wrap="square" lIns="0" tIns="0" rIns="0" bIns="0" anchor="t" anchorCtr="0">
+            <a:noAutofit/>
+          </a:bodyPr>
+          <a:lstStyle/>
+          <a:p>
+            <a:pPr marL="0" marR="0" lvl="0" indent="0" algn="l" rtl="0">
+              <a:lnSpc>
+                <a:spcPct val="157142"/>
+              </a:lnSpc>
+              <a:spcBef>
+                <a:spcPts val="0"/>
+              </a:spcBef>
+              <a:spcAft>
+                <a:spcPts val="0"/>
+              </a:spcAft>
+              <a:buClr>
+                <a:srgbClr val="051D3A"/>
+              </a:buClr>
+              <a:buSzPts val="3500"/>
+              <a:buFont typeface="Times New Roman"/>
+              <a:buNone/>
+            </a:pPr>
+            <a:r>
+              <a:rPr lang="en-US" sz="2400" b="1">
+                <a:sym typeface="Times New Roman"/>
+              </a:rPr>
+              <a:t>Future Scope </a:t>
+            </a:r>
+            <a:endParaRPr sz="2400" b="1">
+              <a:sym typeface="Times New Roman"/>
+            </a:endParaRPr>
+          </a:p>
+        </p:txBody>
+      </p:sp>
+      <p:sp>
+        <p:nvSpPr>
+          <p:cNvPr id="279" name="Google Shape;279;p18">
+            <a:extLst>
+              <a:ext uri="{FF2B5EF4-FFF2-40B4-BE49-F238E27FC236}">
+                <a16:creationId xmlns:a16="http://schemas.microsoft.com/office/drawing/2014/main" id="{EAFA16CB-0A72-5AC5-69A0-ABF4A752B43F}"/>
+              </a:ext>
+            </a:extLst>
+          </p:cNvPr>
+          <p:cNvSpPr/>
+          <p:nvPr/>
+        </p:nvSpPr>
+        <p:spPr>
+          <a:xfrm>
+            <a:off x="1218724" y="1127372"/>
+            <a:ext cx="9214580" cy="4277001"/>
+          </a:xfrm>
+          <a:prstGeom prst="rect">
+            <a:avLst/>
+          </a:prstGeom>
+          <a:noFill/>
+          <a:ln>
+            <a:noFill/>
+          </a:ln>
+        </p:spPr>
+        <p:txBody>
+          <a:bodyPr spcFirstLastPara="1" wrap="square" lIns="0" tIns="0" rIns="0" bIns="0" anchor="t" anchorCtr="0">
+            <a:noAutofit/>
+          </a:bodyPr>
+          <a:lstStyle/>
+          <a:p>
+            <a:pPr>
+              <a:lnSpc>
+                <a:spcPct val="150000"/>
+              </a:lnSpc>
+              <a:buFont typeface="Arial"/>
+              <a:buChar char="•"/>
+            </a:pPr>
+            <a:r>
+              <a:rPr lang="en-US" sz="2000">
+                <a:solidFill>
+                  <a:srgbClr val="2B3541"/>
+                </a:solidFill>
+              </a:rPr>
+              <a:t>Assist healthcare professionals by providing </a:t>
+            </a:r>
+            <a:r>
+              <a:rPr lang="en-US" sz="2000" b="1">
+                <a:solidFill>
+                  <a:srgbClr val="2B3541"/>
+                </a:solidFill>
+              </a:rPr>
+              <a:t>quick and reliable preliminary breast cancer predictions</a:t>
+            </a:r>
+            <a:r>
+              <a:rPr lang="en-US" sz="2000">
+                <a:solidFill>
+                  <a:srgbClr val="2B3541"/>
+                </a:solidFill>
+              </a:rPr>
+              <a:t>, reducing diagnostic time. </a:t>
+            </a:r>
+            <a:endParaRPr lang="en-US" sz="2000"/>
+          </a:p>
+          <a:p>
+            <a:pPr>
+              <a:lnSpc>
+                <a:spcPct val="150000"/>
+              </a:lnSpc>
+              <a:buFont typeface="Arial"/>
+              <a:buChar char="•"/>
+            </a:pPr>
+            <a:r>
+              <a:rPr lang="en-US" sz="2000">
+                <a:solidFill>
+                  <a:srgbClr val="2B3541"/>
+                </a:solidFill>
+              </a:rPr>
+              <a:t>Promote </a:t>
+            </a:r>
+            <a:r>
+              <a:rPr lang="en-US" sz="2000" b="1">
+                <a:solidFill>
+                  <a:srgbClr val="2B3541"/>
+                </a:solidFill>
+              </a:rPr>
+              <a:t>early detection and timely medical intervention</a:t>
+            </a:r>
+            <a:r>
+              <a:rPr lang="en-US" sz="2000">
+                <a:solidFill>
+                  <a:srgbClr val="2B3541"/>
+                </a:solidFill>
+              </a:rPr>
+              <a:t>, improving treatment success rates and patient survival. </a:t>
+            </a:r>
+            <a:endParaRPr lang="en-US" sz="2000"/>
+          </a:p>
+          <a:p>
+            <a:pPr>
+              <a:lnSpc>
+                <a:spcPct val="150000"/>
+              </a:lnSpc>
+              <a:buFont typeface="Arial"/>
+              <a:buChar char="•"/>
+            </a:pPr>
+            <a:r>
+              <a:rPr lang="en-US" sz="2000">
+                <a:solidFill>
+                  <a:srgbClr val="2B3541"/>
+                </a:solidFill>
+              </a:rPr>
+              <a:t>Increase </a:t>
+            </a:r>
+            <a:r>
+              <a:rPr lang="en-US" sz="2000" b="1">
+                <a:solidFill>
+                  <a:srgbClr val="2B3541"/>
+                </a:solidFill>
+              </a:rPr>
+              <a:t>breast cancer awareness</a:t>
+            </a:r>
+            <a:r>
+              <a:rPr lang="en-US" sz="2000">
+                <a:solidFill>
+                  <a:srgbClr val="2B3541"/>
+                </a:solidFill>
+              </a:rPr>
+              <a:t> by educating users about risk factors, symptoms, and preventive measures. </a:t>
+            </a:r>
+            <a:endParaRPr lang="en-US" sz="2000"/>
+          </a:p>
+          <a:p>
+            <a:pPr>
+              <a:lnSpc>
+                <a:spcPct val="150000"/>
+              </a:lnSpc>
+              <a:buFont typeface="Arial"/>
+              <a:buChar char="•"/>
+            </a:pPr>
+            <a:r>
+              <a:rPr lang="en-US" sz="2000">
+                <a:solidFill>
+                  <a:srgbClr val="2B3541"/>
+                </a:solidFill>
+              </a:rPr>
+              <a:t>Be integrated into </a:t>
+            </a:r>
+            <a:r>
+              <a:rPr lang="en-US" sz="2000" b="1">
+                <a:solidFill>
+                  <a:srgbClr val="2B3541"/>
+                </a:solidFill>
+              </a:rPr>
+              <a:t>hospitals, diagnostic centers, and healthcare systems</a:t>
+            </a:r>
+            <a:r>
+              <a:rPr lang="en-US" sz="2000">
+                <a:solidFill>
+                  <a:srgbClr val="2B3541"/>
+                </a:solidFill>
+              </a:rPr>
+              <a:t> as an AI-assisted decision support tool. </a:t>
+            </a:r>
+            <a:endParaRPr lang="en-US" sz="2000"/>
+          </a:p>
+          <a:p>
+            <a:pPr>
+              <a:lnSpc>
+                <a:spcPct val="150000"/>
+              </a:lnSpc>
+              <a:buFont typeface="Arial"/>
+              <a:buChar char="•"/>
+            </a:pPr>
+            <a:r>
+              <a:rPr lang="en-US" sz="2000">
+                <a:solidFill>
+                  <a:srgbClr val="2B3541"/>
+                </a:solidFill>
+              </a:rPr>
+              <a:t>Improve healthcare accessibility by enabling </a:t>
+            </a:r>
+            <a:r>
+              <a:rPr lang="en-US" sz="2000" b="1">
+                <a:solidFill>
+                  <a:srgbClr val="2B3541"/>
+                </a:solidFill>
+              </a:rPr>
+              <a:t>remote breast cancer risk assessment</a:t>
+            </a:r>
+            <a:r>
+              <a:rPr lang="en-US" sz="2000">
+                <a:solidFill>
+                  <a:srgbClr val="2B3541"/>
+                </a:solidFill>
+              </a:rPr>
+              <a:t>, especially for people in rural and underserved areas. </a:t>
+            </a:r>
+            <a:endParaRPr lang="en-US" sz="2000"/>
+          </a:p>
+          <a:p>
+            <a:pPr>
+              <a:lnSpc>
+                <a:spcPct val="150000"/>
+              </a:lnSpc>
+              <a:buFont typeface="Arial"/>
+              <a:buChar char="•"/>
+            </a:pPr>
+            <a:r>
+              <a:rPr lang="en-US" sz="2000">
+                <a:solidFill>
+                  <a:srgbClr val="2B3541"/>
+                </a:solidFill>
+              </a:rPr>
+              <a:t>Support doctors by acting as a </a:t>
+            </a:r>
+            <a:r>
+              <a:rPr lang="en-US" sz="2000" b="1">
+                <a:solidFill>
+                  <a:srgbClr val="2B3541"/>
+                </a:solidFill>
+              </a:rPr>
+              <a:t>clinical decision-support system</a:t>
+            </a:r>
+            <a:r>
+              <a:rPr lang="en-US" sz="2000">
+                <a:solidFill>
+                  <a:srgbClr val="2B3541"/>
+                </a:solidFill>
+              </a:rPr>
+              <a:t>, reducing  </a:t>
+            </a:r>
+            <a:endParaRPr lang="en-US" sz="2000"/>
+          </a:p>
+          <a:p>
+            <a:pPr marL="285750" indent="-285750">
+              <a:lnSpc>
+                <a:spcPct val="150000"/>
+              </a:lnSpc>
+              <a:buFont typeface="Arial"/>
+              <a:buChar char="•"/>
+            </a:pPr>
+            <a:endParaRPr lang="en-US" sz="1850" dirty="0">
+              <a:solidFill>
+                <a:srgbClr val="2B3541"/>
+              </a:solidFill>
+            </a:endParaRPr>
+          </a:p>
+          <a:p>
+            <a:pPr marL="0" marR="0" lvl="0" indent="0" algn="l">
+              <a:lnSpc>
+                <a:spcPct val="150000"/>
+              </a:lnSpc>
+              <a:spcBef>
+                <a:spcPts val="0"/>
+              </a:spcBef>
+              <a:spcAft>
+                <a:spcPts val="0"/>
+              </a:spcAft>
+              <a:buSzPts val="1850"/>
+              <a:buFont typeface="Times New Roman"/>
+              <a:buNone/>
+            </a:pPr>
+            <a:endParaRPr lang="en-US" sz="1850" b="1">
+              <a:solidFill>
+                <a:srgbClr val="2B3541"/>
+              </a:solidFill>
+              <a:latin typeface="Times New Roman"/>
+              <a:cs typeface="Times New Roman"/>
+            </a:endParaRPr>
+          </a:p>
+        </p:txBody>
+      </p:sp>
+      <p:sp>
+        <p:nvSpPr>
+          <p:cNvPr id="280" name="Google Shape;280;p18">
+            <a:extLst>
+              <a:ext uri="{FF2B5EF4-FFF2-40B4-BE49-F238E27FC236}">
+                <a16:creationId xmlns:a16="http://schemas.microsoft.com/office/drawing/2014/main" id="{B888011B-E4AC-77DB-4A60-BE2C891C49F5}"/>
+              </a:ext>
+            </a:extLst>
+          </p:cNvPr>
+          <p:cNvSpPr/>
+          <p:nvPr/>
+        </p:nvSpPr>
+        <p:spPr>
+          <a:xfrm>
+            <a:off x="1218724" y="3360216"/>
+            <a:ext cx="7468553" cy="766048"/>
+          </a:xfrm>
+          <a:prstGeom prst="rect">
+            <a:avLst/>
+          </a:prstGeom>
+          <a:noFill/>
+          <a:ln>
+            <a:noFill/>
+          </a:ln>
+        </p:spPr>
+        <p:txBody>
+          <a:bodyPr spcFirstLastPara="1" wrap="square" lIns="0" tIns="0" rIns="0" bIns="0" anchor="t" anchorCtr="0">
+            <a:noAutofit/>
+          </a:bodyPr>
+          <a:lstStyle/>
+          <a:p>
+            <a:pPr marL="0" marR="0" lvl="0" indent="0" algn="l" rtl="0">
+              <a:lnSpc>
+                <a:spcPct val="162162"/>
+              </a:lnSpc>
+              <a:spcBef>
+                <a:spcPts val="0"/>
+              </a:spcBef>
+              <a:spcAft>
+                <a:spcPts val="0"/>
+              </a:spcAft>
+              <a:buClr>
+                <a:srgbClr val="2B3541"/>
+              </a:buClr>
+              <a:buSzPts val="1850"/>
+              <a:buFont typeface="Times New Roman"/>
+              <a:buNone/>
+            </a:pPr>
+            <a:r>
+              <a:rPr lang="en-US" sz="1850" b="0" i="0" u="none" strike="noStrike" cap="none">
+                <a:solidFill>
+                  <a:srgbClr val="2B3541"/>
+                </a:solidFill>
+                <a:latin typeface="Times New Roman"/>
+                <a:ea typeface="Times New Roman"/>
+                <a:cs typeface="Times New Roman"/>
+                <a:sym typeface="Times New Roman"/>
+              </a:rPr>
+              <a:t>·</a:t>
+            </a:r>
+            <a:endParaRPr sz="1850" b="0" i="0" u="none" strike="noStrike" cap="none">
+              <a:solidFill>
+                <a:srgbClr val="000000"/>
+              </a:solidFill>
+              <a:latin typeface="Times New Roman"/>
+              <a:ea typeface="Times New Roman"/>
+              <a:cs typeface="Times New Roman"/>
+              <a:sym typeface="Times New Roman"/>
+            </a:endParaRPr>
+          </a:p>
+        </p:txBody>
+      </p:sp>
+      <p:sp>
+        <p:nvSpPr>
+          <p:cNvPr id="281" name="Google Shape;281;p18">
+            <a:extLst>
+              <a:ext uri="{FF2B5EF4-FFF2-40B4-BE49-F238E27FC236}">
+                <a16:creationId xmlns:a16="http://schemas.microsoft.com/office/drawing/2014/main" id="{91F05971-9256-10B5-6575-4E7C679C6DAA}"/>
+              </a:ext>
+            </a:extLst>
+          </p:cNvPr>
+          <p:cNvSpPr/>
+          <p:nvPr/>
+        </p:nvSpPr>
+        <p:spPr>
+          <a:xfrm>
+            <a:off x="1218724" y="4395464"/>
+            <a:ext cx="7468553" cy="766048"/>
+          </a:xfrm>
+          <a:prstGeom prst="rect">
+            <a:avLst/>
+          </a:prstGeom>
+          <a:noFill/>
+          <a:ln>
+            <a:noFill/>
+          </a:ln>
+        </p:spPr>
+        <p:txBody>
+          <a:bodyPr spcFirstLastPara="1" wrap="square" lIns="0" tIns="0" rIns="0" bIns="0" anchor="t" anchorCtr="0">
+            <a:noAutofit/>
+          </a:bodyPr>
+          <a:lstStyle/>
+          <a:p>
+            <a:pPr marL="0" marR="0" lvl="0" indent="0" algn="l" rtl="0">
+              <a:lnSpc>
+                <a:spcPct val="162162"/>
+              </a:lnSpc>
+              <a:spcBef>
+                <a:spcPts val="0"/>
+              </a:spcBef>
+              <a:spcAft>
+                <a:spcPts val="0"/>
+              </a:spcAft>
+              <a:buClr>
+                <a:srgbClr val="2B3541"/>
+              </a:buClr>
+              <a:buSzPts val="1850"/>
+              <a:buFont typeface="Times New Roman"/>
+              <a:buNone/>
+            </a:pPr>
+            <a:r>
+              <a:rPr lang="en-US" sz="1850" b="0" i="0" u="none" strike="noStrike" cap="none">
+                <a:solidFill>
+                  <a:srgbClr val="2B3541"/>
+                </a:solidFill>
+                <a:latin typeface="Times New Roman"/>
+                <a:ea typeface="Times New Roman"/>
+                <a:cs typeface="Times New Roman"/>
+                <a:sym typeface="Times New Roman"/>
+              </a:rPr>
+              <a:t>·</a:t>
+            </a:r>
+            <a:endParaRPr sz="1850" b="0" i="0" u="none" strike="noStrike" cap="none">
+              <a:solidFill>
+                <a:srgbClr val="000000"/>
+              </a:solidFill>
+              <a:latin typeface="Times New Roman"/>
+              <a:ea typeface="Times New Roman"/>
+              <a:cs typeface="Times New Roman"/>
+              <a:sym typeface="Times New Roman"/>
+            </a:endParaRPr>
+          </a:p>
+        </p:txBody>
+      </p:sp>
+      <p:sp>
+        <p:nvSpPr>
+          <p:cNvPr id="282" name="Google Shape;282;p18">
+            <a:extLst>
+              <a:ext uri="{FF2B5EF4-FFF2-40B4-BE49-F238E27FC236}">
+                <a16:creationId xmlns:a16="http://schemas.microsoft.com/office/drawing/2014/main" id="{F1C3EBC2-438F-C150-9ABF-F14321C2CC5C}"/>
+              </a:ext>
+            </a:extLst>
+          </p:cNvPr>
+          <p:cNvSpPr/>
+          <p:nvPr/>
+        </p:nvSpPr>
+        <p:spPr>
+          <a:xfrm>
+            <a:off x="1218724" y="5430713"/>
+            <a:ext cx="7468553" cy="383024"/>
+          </a:xfrm>
+          <a:prstGeom prst="rect">
+            <a:avLst/>
+          </a:prstGeom>
+          <a:noFill/>
+          <a:ln>
+            <a:noFill/>
+          </a:ln>
+        </p:spPr>
+        <p:txBody>
+          <a:bodyPr spcFirstLastPara="1" wrap="square" lIns="0" tIns="0" rIns="0" bIns="0" anchor="t" anchorCtr="0">
+            <a:noAutofit/>
+          </a:bodyPr>
+          <a:lstStyle/>
+          <a:p>
+            <a:pPr marL="0" marR="0" lvl="0" indent="0" algn="l" rtl="0">
+              <a:lnSpc>
+                <a:spcPct val="162162"/>
+              </a:lnSpc>
+              <a:spcBef>
+                <a:spcPts val="0"/>
+              </a:spcBef>
+              <a:spcAft>
+                <a:spcPts val="0"/>
+              </a:spcAft>
+              <a:buClr>
+                <a:srgbClr val="2B3541"/>
+              </a:buClr>
+              <a:buSzPts val="1850"/>
+              <a:buFont typeface="Times New Roman"/>
+              <a:buNone/>
+            </a:pPr>
+            <a:r>
+              <a:rPr lang="en-US" sz="1850" b="0" i="0" u="none" strike="noStrike" cap="none">
+                <a:solidFill>
+                  <a:srgbClr val="2B3541"/>
+                </a:solidFill>
+                <a:latin typeface="Times New Roman"/>
+                <a:ea typeface="Times New Roman"/>
+                <a:cs typeface="Times New Roman"/>
+                <a:sym typeface="Times New Roman"/>
+              </a:rPr>
+              <a:t>·</a:t>
+            </a:r>
+            <a:endParaRPr sz="1850" b="0" i="0" u="none" strike="noStrike" cap="none">
+              <a:solidFill>
+                <a:srgbClr val="000000"/>
+              </a:solidFill>
+              <a:latin typeface="Times New Roman"/>
+              <a:ea typeface="Times New Roman"/>
+              <a:cs typeface="Times New Roman"/>
+              <a:sym typeface="Times New Roman"/>
+            </a:endParaRPr>
+          </a:p>
+        </p:txBody>
+      </p:sp>
+    </p:spTree>
+    <p:extLst>
+      <p:ext uri="{BB962C8B-B14F-4D97-AF65-F5344CB8AC3E}">
+        <p14:creationId xmlns:p14="http://schemas.microsoft.com/office/powerpoint/2010/main" val="2136706720"/>
+      </p:ext>
+    </p:extLst>
+  </p:cSld>
+  <p:clrMapOvr>
+    <a:masterClrMapping/>
+  </p:clrMapOvr>
+</p:sld>
+</file>
+
+<file path=ppt/slides/slide32.xml><?xml version="1.0" encoding="utf-8"?>
+<p:sld xmlns:a="http://schemas.openxmlformats.org/drawingml/2006/main" xmlns:r="http://schemas.openxmlformats.org/officeDocument/2006/relationships" xmlns:p="http://schemas.openxmlformats.org/presentationml/2006/main">
+  <p:cSld>
+    <p:spTree>
+      <p:nvGrpSpPr>
+        <p:cNvPr id="1" name=""/>
+        <p:cNvGrpSpPr/>
+        <p:nvPr/>
+      </p:nvGrpSpPr>
+      <p:grpSpPr>
+        <a:xfrm>
+          <a:off x="0" y="0"/>
+          <a:ext cx="0" cy="0"/>
+          <a:chOff x="0" y="0"/>
+          <a:chExt cx="0" cy="0"/>
+        </a:xfrm>
+      </p:grpSpPr>
+      <p:sp>
+        <p:nvSpPr>
+          <p:cNvPr id="4" name="TextBox 3">
+            <a:extLst>
+              <a:ext uri="{FF2B5EF4-FFF2-40B4-BE49-F238E27FC236}">
+                <a16:creationId xmlns:a16="http://schemas.microsoft.com/office/drawing/2014/main" id="{990A5436-28E0-E58C-12FD-233FBF3F3968}"/>
+              </a:ext>
+            </a:extLst>
+          </p:cNvPr>
+          <p:cNvSpPr txBox="1"/>
+          <p:nvPr/>
+        </p:nvSpPr>
+        <p:spPr>
+          <a:xfrm>
+            <a:off x="212595" y="589966"/>
+            <a:ext cx="11533249" cy="2616101"/>
+          </a:xfrm>
+          <a:prstGeom prst="rect">
+            <a:avLst/>
+          </a:prstGeom>
+          <a:noFill/>
+        </p:spPr>
+        <p:txBody>
+          <a:bodyPr rot="0" spcFirstLastPara="0" vertOverflow="overflow" horzOverflow="overflow" vert="horz" wrap="square" lIns="91440" tIns="45720" rIns="91440" bIns="45720" numCol="1" spcCol="0" rtlCol="0" fromWordArt="0" anchor="t" anchorCtr="0" forceAA="0" compatLnSpc="1">
+            <a:prstTxWarp prst="textNoShape">
+              <a:avLst/>
+            </a:prstTxWarp>
+            <a:spAutoFit/>
+          </a:bodyPr>
+          <a:lstStyle/>
+          <a:p>
+            <a:pPr>
+              <a:lnSpc>
+                <a:spcPct val="150000"/>
+              </a:lnSpc>
+            </a:pPr>
+            <a:r>
+              <a:rPr lang="en-US" sz="2000">
+                <a:solidFill>
+                  <a:srgbClr val="2B3541"/>
+                </a:solidFill>
+              </a:rPr>
+              <a:t>    manual effort and assisting in data-driven diagnosis.</a:t>
+            </a:r>
+            <a:endParaRPr lang="en-US" sz="2000" dirty="0">
+              <a:solidFill>
+                <a:srgbClr val="2B3541"/>
+              </a:solidFill>
+            </a:endParaRPr>
+          </a:p>
+          <a:p>
+            <a:pPr marL="285750" indent="-285750">
+              <a:lnSpc>
+                <a:spcPct val="150000"/>
+              </a:lnSpc>
+              <a:buFont typeface="Arial,Sans-Serif"/>
+              <a:buChar char="•"/>
+            </a:pPr>
+            <a:r>
+              <a:rPr lang="en-US" sz="2000">
+                <a:solidFill>
+                  <a:srgbClr val="2B3541"/>
+                </a:solidFill>
+              </a:rPr>
+              <a:t>Expand into a comprehensive healthcare platform capable of predicting </a:t>
+            </a:r>
+            <a:r>
+              <a:rPr lang="en-US" sz="2000" b="1">
+                <a:solidFill>
+                  <a:srgbClr val="2B3541"/>
+                </a:solidFill>
+              </a:rPr>
+              <a:t>multiple diseases</a:t>
+            </a:r>
+            <a:r>
+              <a:rPr lang="en-US" sz="2000">
+                <a:solidFill>
+                  <a:srgbClr val="2B3541"/>
+                </a:solidFill>
+              </a:rPr>
+              <a:t> using advanced AI and machine learning models. </a:t>
+            </a:r>
+            <a:endParaRPr lang="en-US" sz="2000"/>
+          </a:p>
+          <a:p>
+            <a:pPr marL="285750" indent="-285750">
+              <a:lnSpc>
+                <a:spcPct val="150000"/>
+              </a:lnSpc>
+              <a:buFont typeface="Arial,Sans-Serif"/>
+              <a:buChar char="•"/>
+            </a:pPr>
+            <a:r>
+              <a:rPr lang="en-US" sz="2000">
+                <a:solidFill>
+                  <a:srgbClr val="2B3541"/>
+                </a:solidFill>
+              </a:rPr>
+              <a:t>Contribute to the advancement of </a:t>
+            </a:r>
+            <a:r>
+              <a:rPr lang="en-US" sz="2000" b="1">
+                <a:solidFill>
+                  <a:srgbClr val="2B3541"/>
+                </a:solidFill>
+              </a:rPr>
+              <a:t>AI-powered healthcare</a:t>
+            </a:r>
+            <a:r>
+              <a:rPr lang="en-US" sz="2000">
+                <a:solidFill>
+                  <a:srgbClr val="2B3541"/>
+                </a:solidFill>
+              </a:rPr>
+              <a:t>, making medical screening faster, more accurate, and accessible to a larger population.</a:t>
+            </a:r>
+            <a:endParaRPr lang="en-US" sz="2000"/>
+          </a:p>
+          <a:p>
+            <a:pPr algn="l"/>
+            <a:endParaRPr lang="en-US" dirty="0"/>
+          </a:p>
+        </p:txBody>
+      </p:sp>
+    </p:spTree>
+    <p:extLst>
+      <p:ext uri="{BB962C8B-B14F-4D97-AF65-F5344CB8AC3E}">
+        <p14:creationId xmlns:p14="http://schemas.microsoft.com/office/powerpoint/2010/main" val="215885403"/>
+      </p:ext>
+    </p:extLst>
+  </p:cSld>
+  <p:clrMapOvr>
+    <a:masterClrMapping/>
+  </p:clrMapOvr>
+</p:sld>
+</file>
+
+<file path=ppt/slides/slide33.xml><?xml version="1.0" encoding="utf-8"?>
+<p:sld xmlns:a="http://schemas.openxmlformats.org/drawingml/2006/main" xmlns:r="http://schemas.openxmlformats.org/officeDocument/2006/relationships" xmlns:p="http://schemas.openxmlformats.org/presentationml/2006/main">
+  <p:cSld>
+    <p:spTree>
+      <p:nvGrpSpPr>
         <p:cNvPr id="1" name=""/>
         <p:cNvGrpSpPr/>
         <p:nvPr/>
@@ -15877,7 +16313,7 @@
 </p:sld>
 </file>
 
-<file path=ppt/slides/slide31.xml><?xml version="1.0" encoding="utf-8"?>
+<file path=ppt/slides/slide34.xml><?xml version="1.0" encoding="utf-8"?>
 <p:sld xmlns:a="http://schemas.openxmlformats.org/drawingml/2006/main" xmlns:r="http://schemas.openxmlformats.org/officeDocument/2006/relationships" xmlns:p="http://schemas.openxmlformats.org/presentationml/2006/main">
   <p:cSld>
     <p:spTree>
@@ -15937,7 +16373,7 @@
 </p:sld>
 </file>
 
-<file path=ppt/slides/slide32.xml><?xml version="1.0" encoding="utf-8"?>
+<file path=ppt/slides/slide35.xml><?xml version="1.0" encoding="utf-8"?>
 <p:sld xmlns:a="http://schemas.openxmlformats.org/drawingml/2006/main" xmlns:r="http://schemas.openxmlformats.org/officeDocument/2006/relationships" xmlns:p="http://schemas.openxmlformats.org/presentationml/2006/main">
   <p:cSld>
     <p:spTree>
@@ -15997,7 +16433,7 @@
 </p:sld>
 </file>
 
-<file path=ppt/slides/slide33.xml><?xml version="1.0" encoding="utf-8"?>
+<file path=ppt/slides/slide36.xml><?xml version="1.0" encoding="utf-8"?>
 <p:sld xmlns:a="http://schemas.openxmlformats.org/drawingml/2006/main" xmlns:r="http://schemas.openxmlformats.org/officeDocument/2006/relationships" xmlns:p="http://schemas.openxmlformats.org/presentationml/2006/main">
   <p:cSld>
     <p:spTree>
@@ -16057,7 +16493,7 @@
 </p:sld>
 </file>
 
-<file path=ppt/slides/slide34.xml><?xml version="1.0" encoding="utf-8"?>
+<file path=ppt/slides/slide37.xml><?xml version="1.0" encoding="utf-8"?>
 <p:sld xmlns:a="http://schemas.openxmlformats.org/drawingml/2006/main" xmlns:r="http://schemas.openxmlformats.org/officeDocument/2006/relationships" xmlns:p="http://schemas.openxmlformats.org/presentationml/2006/main">
   <p:cSld>
     <p:spTree>
@@ -16117,7 +16553,7 @@
 </p:sld>
 </file>
 
-<file path=ppt/slides/slide35.xml><?xml version="1.0" encoding="utf-8"?>
+<file path=ppt/slides/slide38.xml><?xml version="1.0" encoding="utf-8"?>
 <p:sld xmlns:a="http://schemas.openxmlformats.org/drawingml/2006/main" xmlns:r="http://schemas.openxmlformats.org/officeDocument/2006/relationships" xmlns:p="http://schemas.openxmlformats.org/presentationml/2006/main">
   <p:cSld>
     <p:spTree>
@@ -16177,7 +16613,7 @@
 </p:sld>
 </file>
 
-<file path=ppt/slides/slide36.xml><?xml version="1.0" encoding="utf-8"?>
+<file path=ppt/slides/slide39.xml><?xml version="1.0" encoding="utf-8"?>
 <p:sld xmlns:a="http://schemas.openxmlformats.org/drawingml/2006/main" xmlns:r="http://schemas.openxmlformats.org/officeDocument/2006/relationships" xmlns:p="http://schemas.openxmlformats.org/presentationml/2006/main">
   <p:cSld>
     <p:spTree>

</xml_diff>